<commit_message>
Bring the deck up to the meeting it now describes
The walkthrough predated the agenda work, so it still showed a game-first
meeting with no agenda, notes, outcomes or exports. It now follows the
product as it stands: joining, the two ways to open, the optional game,
the agenda carrying the room (1 of 4, outcomes, notes, ideas, decisions,
actions), a phone following along, the wrap, and the minutes in all three
formats including the branded PDF.

Every picture is a fresh capture of the deployed app, including the larger
mshikaki mark.
</commit_message>
<xml_diff>
--- a/docs/presentations/Mshikaki-Walkthrough.pptx
+++ b/docs/presentations/Mshikaki-Walkthrough.pptx
@@ -2,25 +2,26 @@
 <file path=ppt/presentation.xml><?xml version="1.0" encoding="utf-8"?>
 <p:presentation xmlns:p="http://schemas.openxmlformats.org/presentationml/2006/main">
   <p:sldMasterIdLst>
-    <p:sldMasterId xmlns:r="http://schemas.openxmlformats.org/officeDocument/2006/relationships" id="2147483648" r:id="Rdb7b439b649f42fc"/>
+    <p:sldMasterId xmlns:r="http://schemas.openxmlformats.org/officeDocument/2006/relationships" id="2147483648" r:id="R4ef1d39efc634394"/>
   </p:sldMasterIdLst>
   <p:notesMasterIdLst>
-    <p:notesMasterId xmlns:r="http://schemas.openxmlformats.org/officeDocument/2006/relationships" r:id="R4b59d2f84f924a82"/>
+    <p:notesMasterId xmlns:r="http://schemas.openxmlformats.org/officeDocument/2006/relationships" r:id="Ra9204c0296fb428e"/>
   </p:notesMasterIdLst>
   <p:sldIdLst>
-    <p:sldId xmlns:r="http://schemas.openxmlformats.org/officeDocument/2006/relationships" id="256" r:id="R2fa9cac767b8421b"/>
-    <p:sldId xmlns:r="http://schemas.openxmlformats.org/officeDocument/2006/relationships" id="257" r:id="R53182412e9fa4260"/>
-    <p:sldId xmlns:r="http://schemas.openxmlformats.org/officeDocument/2006/relationships" id="258" r:id="Rf6fa52633d284f45"/>
-    <p:sldId xmlns:r="http://schemas.openxmlformats.org/officeDocument/2006/relationships" id="259" r:id="R6b4bed9d8dad49ba"/>
-    <p:sldId xmlns:r="http://schemas.openxmlformats.org/officeDocument/2006/relationships" id="260" r:id="R64b404fbb8a14111"/>
-    <p:sldId xmlns:r="http://schemas.openxmlformats.org/officeDocument/2006/relationships" id="261" r:id="R994ead2ce4d84d85"/>
-    <p:sldId xmlns:r="http://schemas.openxmlformats.org/officeDocument/2006/relationships" id="262" r:id="R40cea8817cbb4d26"/>
-    <p:sldId xmlns:r="http://schemas.openxmlformats.org/officeDocument/2006/relationships" id="263" r:id="Ref1eee34b4f64be4"/>
-    <p:sldId xmlns:r="http://schemas.openxmlformats.org/officeDocument/2006/relationships" id="264" r:id="R0376bfc32e634d07"/>
-    <p:sldId xmlns:r="http://schemas.openxmlformats.org/officeDocument/2006/relationships" id="265" r:id="R5df7568a343a4316"/>
-    <p:sldId xmlns:r="http://schemas.openxmlformats.org/officeDocument/2006/relationships" id="266" r:id="Ra0667a2562bd4dce"/>
-    <p:sldId xmlns:r="http://schemas.openxmlformats.org/officeDocument/2006/relationships" id="267" r:id="Ra7537f28fa534c7f"/>
-    <p:sldId xmlns:r="http://schemas.openxmlformats.org/officeDocument/2006/relationships" id="268" r:id="R237a5505e73f4a30"/>
+    <p:sldId xmlns:r="http://schemas.openxmlformats.org/officeDocument/2006/relationships" id="256" r:id="R4a8d23a8b28d4f08"/>
+    <p:sldId xmlns:r="http://schemas.openxmlformats.org/officeDocument/2006/relationships" id="257" r:id="R13b0e5d55f844cc3"/>
+    <p:sldId xmlns:r="http://schemas.openxmlformats.org/officeDocument/2006/relationships" id="258" r:id="Rdee4da3d7d95467f"/>
+    <p:sldId xmlns:r="http://schemas.openxmlformats.org/officeDocument/2006/relationships" id="259" r:id="Ra8709e21a8cf47e2"/>
+    <p:sldId xmlns:r="http://schemas.openxmlformats.org/officeDocument/2006/relationships" id="260" r:id="R60c473d6415f4cd2"/>
+    <p:sldId xmlns:r="http://schemas.openxmlformats.org/officeDocument/2006/relationships" id="261" r:id="Rfb0b9f10f22c43a6"/>
+    <p:sldId xmlns:r="http://schemas.openxmlformats.org/officeDocument/2006/relationships" id="262" r:id="R389924ffbde849fc"/>
+    <p:sldId xmlns:r="http://schemas.openxmlformats.org/officeDocument/2006/relationships" id="263" r:id="Rfa8e0455d4fa4470"/>
+    <p:sldId xmlns:r="http://schemas.openxmlformats.org/officeDocument/2006/relationships" id="264" r:id="Rcfdaa59cf0ed4efb"/>
+    <p:sldId xmlns:r="http://schemas.openxmlformats.org/officeDocument/2006/relationships" id="265" r:id="R1cd5bb64cd4843b8"/>
+    <p:sldId xmlns:r="http://schemas.openxmlformats.org/officeDocument/2006/relationships" id="266" r:id="R51535193295e4638"/>
+    <p:sldId xmlns:r="http://schemas.openxmlformats.org/officeDocument/2006/relationships" id="267" r:id="Raa86770aa4d14566"/>
+    <p:sldId xmlns:r="http://schemas.openxmlformats.org/officeDocument/2006/relationships" id="268" r:id="Rf25c96cc5ca341ac"/>
+    <p:sldId xmlns:r="http://schemas.openxmlformats.org/officeDocument/2006/relationships" id="269" r:id="Rc670c5968fea4335"/>
   </p:sldIdLst>
   <p:sldSz cx="12192000" cy="6858000"/>
   <p:notesSz cx="6858000" cy="9144000"/>
@@ -452,11 +453,7 @@
         <p:txBody>
           <a:bodyPr xmlns:a="http://schemas.openxmlformats.org/drawingml/2006/main"/>
           <a:lstStyle xmlns:a="http://schemas.openxmlformats.org/drawingml/2006/main"/>
-          <a:p xmlns:a="http://schemas.openxmlformats.org/drawingml/2006/main">
-            <a:r>
-              <a:t>Screens captured from the deployed app at 172.16.1.36:8090 on 1 October 2026.</a:t>
-            </a:r>
-          </a:p>
+          <a:p xmlns:a="http://schemas.openxmlformats.org/drawingml/2006/main"/>
         </p:txBody>
       </p:sp>
       <p:sp>
@@ -748,6 +745,72 @@
 </p:notes>
 </file>
 
+<file path=ppt/notesSlides/notesSlide14.xml><?xml version="1.0" encoding="utf-8"?>
+<p:notes xmlns:p="http://schemas.openxmlformats.org/presentationml/2006/main">
+  <p:cSld>
+    <p:spTree>
+      <p:nvGrpSpPr>
+        <p:cNvPr id="1" name=""/>
+        <p:cNvGrpSpPr/>
+        <p:nvPr/>
+      </p:nvGrpSpPr>
+      <p:grpSpPr>
+        <a:xfrm xmlns:a="http://schemas.openxmlformats.org/drawingml/2006/main"/>
+      </p:grpSpPr>
+      <p:sp>
+        <p:nvSpPr>
+          <p:cNvPr id="2" name="Slide Image Placeholder 1"/>
+          <p:cNvSpPr>
+            <a:spLocks xmlns:a="http://schemas.openxmlformats.org/drawingml/2006/main" noGrp="1"/>
+          </p:cNvSpPr>
+          <p:nvPr>
+            <p:ph type="sldImg" idx="0"/>
+          </p:nvPr>
+        </p:nvSpPr>
+        <p:spPr/>
+      </p:sp>
+      <p:sp>
+        <p:nvSpPr>
+          <p:cNvPr id="3" name="Notes Placeholder 2"/>
+          <p:cNvSpPr>
+            <a:spLocks xmlns:a="http://schemas.openxmlformats.org/drawingml/2006/main" noGrp="1"/>
+          </p:cNvSpPr>
+          <p:nvPr>
+            <p:ph type="body" idx="1"/>
+          </p:nvPr>
+        </p:nvSpPr>
+        <p:spPr/>
+        <p:txBody>
+          <a:bodyPr xmlns:a="http://schemas.openxmlformats.org/drawingml/2006/main"/>
+          <a:lstStyle xmlns:a="http://schemas.openxmlformats.org/drawingml/2006/main"/>
+          <a:p xmlns:a="http://schemas.openxmlformats.org/drawingml/2006/main"/>
+        </p:txBody>
+      </p:sp>
+      <p:sp>
+        <p:nvSpPr>
+          <p:cNvPr id="4" name="Slide Number Placeholder 3"/>
+          <p:cNvSpPr>
+            <a:spLocks xmlns:a="http://schemas.openxmlformats.org/drawingml/2006/main" noGrp="1"/>
+          </p:cNvSpPr>
+          <p:nvPr>
+            <p:ph type="sldNum" idx="5"/>
+          </p:nvPr>
+        </p:nvSpPr>
+        <p:spPr/>
+        <p:txBody>
+          <a:bodyPr xmlns:a="http://schemas.openxmlformats.org/drawingml/2006/main"/>
+          <a:lstStyle xmlns:a="http://schemas.openxmlformats.org/drawingml/2006/main"/>
+          <a:p xmlns:a="http://schemas.openxmlformats.org/drawingml/2006/main"/>
+        </p:txBody>
+      </p:sp>
+    </p:spTree>
+  </p:cSld>
+  <p:clrMapOvr>
+    <a:masterClrMapping xmlns:a="http://schemas.openxmlformats.org/drawingml/2006/main"/>
+  </p:clrMapOvr>
+</p:notes>
+</file>
+
 <file path=ppt/notesSlides/notesSlide2.xml><?xml version="1.0" encoding="utf-8"?>
 <p:notes xmlns:p="http://schemas.openxmlformats.org/presentationml/2006/main">
   <p:cSld>
@@ -1293,7 +1356,7 @@
           <p:cNvPr id="3" name="Title">
             <a:extLst xmlns:a="http://schemas.openxmlformats.org/drawingml/2006/main">
               <a:ext uri="{FF2B5EF4-FFF2-40B4-BE49-F238E27FC236}">
-                <a16:creationId xmlns:a16="http://schemas.microsoft.com/office/drawing/2014/main" id="{F4AB5BC6-0561-41AA-BB10-C678FEF331DC}"/>
+                <a16:creationId xmlns:a16="http://schemas.microsoft.com/office/drawing/2014/main" id="{7814B668-2AD6-4FF5-AF0C-58318ADE4E18}"/>
               </a:ext>
             </a:extLst>
           </p:cNvPr>
@@ -1459,7 +1522,7 @@
           <p:cNvPr id="2" name="Subtitle">
             <a:extLst xmlns:a="http://schemas.openxmlformats.org/drawingml/2006/main">
               <a:ext uri="{FF2B5EF4-FFF2-40B4-BE49-F238E27FC236}">
-                <a16:creationId xmlns:a16="http://schemas.microsoft.com/office/drawing/2014/main" id="{EE4D50B8-1BCC-4C1C-ABF2-96F3452F7B02}"/>
+                <a16:creationId xmlns:a16="http://schemas.microsoft.com/office/drawing/2014/main" id="{41038E98-3029-4982-B5C5-335D961F0F72}"/>
               </a:ext>
             </a:extLst>
           </p:cNvPr>
@@ -1642,7 +1705,7 @@
           <p:cNvPr id="2" name="Section title">
             <a:extLst xmlns:a="http://schemas.openxmlformats.org/drawingml/2006/main">
               <a:ext uri="{FF2B5EF4-FFF2-40B4-BE49-F238E27FC236}">
-                <a16:creationId xmlns:a16="http://schemas.microsoft.com/office/drawing/2014/main" id="{8F2F1C6D-1175-401F-BEB3-2BBC76B6B70D}"/>
+                <a16:creationId xmlns:a16="http://schemas.microsoft.com/office/drawing/2014/main" id="{F15BD037-B777-478D-8A6E-B859146CC7C4}"/>
               </a:ext>
             </a:extLst>
           </p:cNvPr>
@@ -1825,7 +1888,7 @@
           <p:cNvPr id="3" name="Title">
             <a:extLst xmlns:a="http://schemas.openxmlformats.org/drawingml/2006/main">
               <a:ext uri="{FF2B5EF4-FFF2-40B4-BE49-F238E27FC236}">
-                <a16:creationId xmlns:a16="http://schemas.microsoft.com/office/drawing/2014/main" id="{EFBE2407-E7F9-4954-862D-7D3470F22A68}"/>
+                <a16:creationId xmlns:a16="http://schemas.microsoft.com/office/drawing/2014/main" id="{225BD0E3-CA72-495C-8ED1-1B063F2AF04A}"/>
               </a:ext>
             </a:extLst>
           </p:cNvPr>
@@ -1991,7 +2054,7 @@
           <p:cNvPr id="2" name="Body">
             <a:extLst xmlns:a="http://schemas.openxmlformats.org/drawingml/2006/main">
               <a:ext uri="{FF2B5EF4-FFF2-40B4-BE49-F238E27FC236}">
-                <a16:creationId xmlns:a16="http://schemas.microsoft.com/office/drawing/2014/main" id="{64636289-FACB-4E28-9145-EFB9ED24AC51}"/>
+                <a16:creationId xmlns:a16="http://schemas.microsoft.com/office/drawing/2014/main" id="{57E0DA1E-EF16-49D1-98B6-731928822BFA}"/>
               </a:ext>
             </a:extLst>
           </p:cNvPr>
@@ -2174,7 +2237,7 @@
           <p:cNvPr id="4" name="Title">
             <a:extLst xmlns:a="http://schemas.openxmlformats.org/drawingml/2006/main">
               <a:ext uri="{FF2B5EF4-FFF2-40B4-BE49-F238E27FC236}">
-                <a16:creationId xmlns:a16="http://schemas.microsoft.com/office/drawing/2014/main" id="{30D9E673-E1F1-4460-8C03-FFB1E7578E7D}"/>
+                <a16:creationId xmlns:a16="http://schemas.microsoft.com/office/drawing/2014/main" id="{CA719670-E652-4A67-8C76-1FAAF856F4B3}"/>
               </a:ext>
             </a:extLst>
           </p:cNvPr>
@@ -2340,7 +2403,7 @@
           <p:cNvPr id="2" name="Left column">
             <a:extLst xmlns:a="http://schemas.openxmlformats.org/drawingml/2006/main">
               <a:ext uri="{FF2B5EF4-FFF2-40B4-BE49-F238E27FC236}">
-                <a16:creationId xmlns:a16="http://schemas.microsoft.com/office/drawing/2014/main" id="{A0D0646E-64D1-4C70-B277-8496C02EAB6D}"/>
+                <a16:creationId xmlns:a16="http://schemas.microsoft.com/office/drawing/2014/main" id="{85281F6E-59EF-4F2A-A571-9E82DA211186}"/>
               </a:ext>
             </a:extLst>
           </p:cNvPr>
@@ -2506,7 +2569,7 @@
           <p:cNvPr id="3" name="Right column">
             <a:extLst xmlns:a="http://schemas.openxmlformats.org/drawingml/2006/main">
               <a:ext uri="{FF2B5EF4-FFF2-40B4-BE49-F238E27FC236}">
-                <a16:creationId xmlns:a16="http://schemas.microsoft.com/office/drawing/2014/main" id="{D7003B98-FE2D-4E5E-BE2B-40EBC02FDA4A}"/>
+                <a16:creationId xmlns:a16="http://schemas.microsoft.com/office/drawing/2014/main" id="{2A4D5E32-3C87-4C14-9819-DAB70EB3637B}"/>
               </a:ext>
             </a:extLst>
           </p:cNvPr>
@@ -2689,7 +2752,7 @@
           <p:cNvPr id="3" name="Title">
             <a:extLst xmlns:a="http://schemas.openxmlformats.org/drawingml/2006/main">
               <a:ext uri="{FF2B5EF4-FFF2-40B4-BE49-F238E27FC236}">
-                <a16:creationId xmlns:a16="http://schemas.microsoft.com/office/drawing/2014/main" id="{E004D6FA-B2C5-40A3-94BC-8352E8B30363}"/>
+                <a16:creationId xmlns:a16="http://schemas.microsoft.com/office/drawing/2014/main" id="{3840D317-9D4A-42A1-A955-EEE209800B0A}"/>
               </a:ext>
             </a:extLst>
           </p:cNvPr>
@@ -2855,7 +2918,7 @@
           <p:cNvPr id="2" name="Left column">
             <a:extLst xmlns:a="http://schemas.openxmlformats.org/drawingml/2006/main">
               <a:ext uri="{FF2B5EF4-FFF2-40B4-BE49-F238E27FC236}">
-                <a16:creationId xmlns:a16="http://schemas.microsoft.com/office/drawing/2014/main" id="{CF21460C-6D61-4DB8-96F3-16E38F9AEE71}"/>
+                <a16:creationId xmlns:a16="http://schemas.microsoft.com/office/drawing/2014/main" id="{778CF4BD-B537-446A-8023-A9EC65661074}"/>
               </a:ext>
             </a:extLst>
           </p:cNvPr>
@@ -3059,12 +3122,12 @@
   </p:cSld>
   <p:clrMap bg1="lt1" tx1="dk1" bg2="lt2" tx2="dk2" accent1="accent1" accent2="accent2" accent3="accent3" accent4="accent4" accent5="accent5" accent6="accent6" hlink="hlink" folHlink="folHlink"/>
   <p:sldLayoutIdLst>
-    <p:sldLayoutId xmlns:r="http://schemas.openxmlformats.org/officeDocument/2006/relationships" id="2147483649" r:id="R85c3bb8b20bc42f6"/>
-    <p:sldLayoutId xmlns:r="http://schemas.openxmlformats.org/officeDocument/2006/relationships" id="2147483650" r:id="Rfddda797e82d47c5"/>
-    <p:sldLayoutId xmlns:r="http://schemas.openxmlformats.org/officeDocument/2006/relationships" id="2147483651" r:id="R1c60d16622c64e11"/>
-    <p:sldLayoutId xmlns:r="http://schemas.openxmlformats.org/officeDocument/2006/relationships" id="2147483652" r:id="Rfc8266b8432a4a79"/>
-    <p:sldLayoutId xmlns:r="http://schemas.openxmlformats.org/officeDocument/2006/relationships" id="2147483653" r:id="R2cacb075fe864f57"/>
-    <p:sldLayoutId xmlns:r="http://schemas.openxmlformats.org/officeDocument/2006/relationships" id="2147483654" r:id="Rf73f0d0879fd4bd0"/>
+    <p:sldLayoutId xmlns:r="http://schemas.openxmlformats.org/officeDocument/2006/relationships" id="2147483649" r:id="Rf053b37ab289467c"/>
+    <p:sldLayoutId xmlns:r="http://schemas.openxmlformats.org/officeDocument/2006/relationships" id="2147483650" r:id="Rde40b1078edc4e38"/>
+    <p:sldLayoutId xmlns:r="http://schemas.openxmlformats.org/officeDocument/2006/relationships" id="2147483651" r:id="R226a812eb7bc41e2"/>
+    <p:sldLayoutId xmlns:r="http://schemas.openxmlformats.org/officeDocument/2006/relationships" id="2147483652" r:id="R614f60d2565d41bd"/>
+    <p:sldLayoutId xmlns:r="http://schemas.openxmlformats.org/officeDocument/2006/relationships" id="2147483653" r:id="R6e558229c16d4e11"/>
+    <p:sldLayoutId xmlns:r="http://schemas.openxmlformats.org/officeDocument/2006/relationships" id="2147483654" r:id="R303016b930b74801"/>
   </p:sldLayoutIdLst>
   <p:txStyles>
     <p:titleStyle>
@@ -3610,23 +3673,53 @@
       <p:grpSpPr>
         <a:xfrm xmlns:a="http://schemas.openxmlformats.org/drawingml/2006/main"/>
       </p:grpSpPr>
-      <p:sp>
-        <p:nvSpPr>
-          <p:cNvPr id="5" name="">
+      <p:pic>
+        <p:nvPicPr>
+          <p:cNvPr id="6" name="">
             <a:extLst xmlns:a="http://schemas.openxmlformats.org/drawingml/2006/main">
               <a:ext uri="{FF2B5EF4-FFF2-40B4-BE49-F238E27FC236}">
-                <a16:creationId xmlns:a16="http://schemas.microsoft.com/office/drawing/2014/main" id="{DFE88ACE-D220-4FD1-99D7-1DE02D76069C}"/>
+                <a16:creationId xmlns:a16="http://schemas.microsoft.com/office/drawing/2014/main" id="{E8E63CF5-D667-4EF4-9862-716122153306}"/>
               </a:ext>
             </a:extLst>
           </p:cNvPr>
-          <p:cNvSpPr>
-            <a:spLocks xmlns:a="http://schemas.openxmlformats.org/drawingml/2006/main" noGrp="1"/>
-          </p:cNvSpPr>
+          <p:cNvPicPr>
+            <a:picLocks xmlns:a="http://schemas.openxmlformats.org/drawingml/2006/main" noChangeAspect="1"/>
+          </p:cNvPicPr>
           <p:nvPr/>
-        </p:nvSpPr>
+        </p:nvPicPr>
+        <p:blipFill>
+          <a:blip xmlns:r="http://schemas.openxmlformats.org/officeDocument/2006/relationships" xmlns:a="http://schemas.openxmlformats.org/drawingml/2006/main" r:embed="Rd705f1337c7242fa"/>
+          <a:stretch xmlns:a="http://schemas.openxmlformats.org/drawingml/2006/main"/>
+        </p:blipFill>
         <p:spPr>
           <a:xfrm xmlns:a="http://schemas.openxmlformats.org/drawingml/2006/main">
-            <a:off x="685800" y="1809750"/>
+            <a:off x="685800" y="914400"/>
+            <a:ext cx="914400" cy="914400"/>
+          </a:xfrm>
+          <a:prstGeom xmlns:a="http://schemas.openxmlformats.org/drawingml/2006/main" prst="roundRect">
+            <a:avLst>
+              <a:gd name="adj" fmla="val 16667"/>
+            </a:avLst>
+          </a:prstGeom>
+        </p:spPr>
+      </p:pic>
+      <p:sp>
+        <p:nvSpPr>
+          <p:cNvPr id="2" name="">
+            <a:extLst xmlns:a="http://schemas.openxmlformats.org/drawingml/2006/main">
+              <a:ext uri="{FF2B5EF4-FFF2-40B4-BE49-F238E27FC236}">
+                <a16:creationId xmlns:a16="http://schemas.microsoft.com/office/drawing/2014/main" id="{FDB9C91B-B5A6-45A9-B59D-CC9F8196553A}"/>
+              </a:ext>
+            </a:extLst>
+          </p:cNvPr>
+          <p:cNvSpPr>
+            <a:spLocks xmlns:a="http://schemas.openxmlformats.org/drawingml/2006/main" noGrp="1"/>
+          </p:cNvSpPr>
+          <p:nvPr/>
+        </p:nvSpPr>
+        <p:spPr>
+          <a:xfrm xmlns:a="http://schemas.openxmlformats.org/drawingml/2006/main">
+            <a:off x="685800" y="2038350"/>
             <a:ext cx="4953000" cy="857250"/>
           </a:xfrm>
           <a:prstGeom xmlns:a="http://schemas.openxmlformats.org/drawingml/2006/main" prst="rect">
@@ -3643,7 +3736,7 @@
           </a:bodyPr>
           <a:lstStyle xmlns:a="http://schemas.openxmlformats.org/drawingml/2006/main">
             <a:defPPr algn="l">
-              <a:defRPr sz="4650" b="1">
+              <a:defRPr sz="4500" b="1">
                 <a:solidFill>
                   <a:srgbClr val="FFFFFF"/>
                 </a:solidFill>
@@ -3659,7 +3752,7 @@
                 <a:spcPct val="115000"/>
               </a:lnSpc>
               <a:buNone/>
-              <a:defRPr sz="4650" b="1">
+              <a:defRPr sz="4500" b="1">
                 <a:solidFill>
                   <a:srgbClr val="FFFFFF"/>
                 </a:solidFill>
@@ -3669,7 +3762,7 @@
               </a:defRPr>
             </a:pPr>
             <a:r>
-              <a:rPr sz="4650" b="1">
+              <a:rPr sz="4500" b="1">
                 <a:solidFill>
                   <a:srgbClr val="FFFFFF"/>
                 </a:solidFill>
@@ -3684,10 +3777,10 @@
       </p:sp>
       <p:sp>
         <p:nvSpPr>
-          <p:cNvPr id="2" name="">
+          <p:cNvPr id="3" name="">
             <a:extLst xmlns:a="http://schemas.openxmlformats.org/drawingml/2006/main">
               <a:ext uri="{FF2B5EF4-FFF2-40B4-BE49-F238E27FC236}">
-                <a16:creationId xmlns:a16="http://schemas.microsoft.com/office/drawing/2014/main" id="{BF83B207-2277-497E-B76A-78849BB46DF3}"/>
+                <a16:creationId xmlns:a16="http://schemas.microsoft.com/office/drawing/2014/main" id="{845AAB0E-1274-48D2-A1F6-20F82FBCE543}"/>
               </a:ext>
             </a:extLst>
           </p:cNvPr>
@@ -3698,8 +3791,8 @@
         </p:nvSpPr>
         <p:spPr>
           <a:xfrm xmlns:a="http://schemas.openxmlformats.org/drawingml/2006/main">
-            <a:off x="685800" y="2857500"/>
-            <a:ext cx="4953000" cy="1047750"/>
+            <a:off x="685800" y="3009900"/>
+            <a:ext cx="4762500" cy="1047750"/>
           </a:xfrm>
           <a:prstGeom xmlns:a="http://schemas.openxmlformats.org/drawingml/2006/main" prst="rect">
             <a:avLst/>
@@ -3715,7 +3808,7 @@
           </a:bodyPr>
           <a:lstStyle xmlns:a="http://schemas.openxmlformats.org/drawingml/2006/main">
             <a:defPPr algn="l">
-              <a:defRPr sz="1800" b="0">
+              <a:defRPr sz="1725" b="0">
                 <a:solidFill>
                   <a:srgbClr val="E8E2DB"/>
                 </a:solidFill>
@@ -3731,7 +3824,7 @@
                 <a:spcPct val="130000"/>
               </a:lnSpc>
               <a:buNone/>
-              <a:defRPr sz="1800" b="0">
+              <a:defRPr sz="1725" b="0">
                 <a:solidFill>
                   <a:srgbClr val="E8E2DB"/>
                 </a:solidFill>
@@ -3741,7 +3834,7 @@
               </a:defRPr>
             </a:pPr>
             <a:r>
-              <a:rPr sz="1800" b="0">
+              <a:rPr sz="1725" b="0">
                 <a:solidFill>
                   <a:srgbClr val="E8E2DB"/>
                 </a:solidFill>
@@ -3758,7 +3851,7 @@
                 <a:spcPct val="130000"/>
               </a:lnSpc>
               <a:buNone/>
-              <a:defRPr sz="1800" b="0">
+              <a:defRPr sz="1725" b="0">
                 <a:solidFill>
                   <a:srgbClr val="E8E2DB"/>
                 </a:solidFill>
@@ -3768,7 +3861,7 @@
               </a:defRPr>
             </a:pPr>
             <a:r>
-              <a:rPr sz="1800" b="0">
+              <a:rPr sz="1725" b="0">
                 <a:solidFill>
                   <a:srgbClr val="E8E2DB"/>
                 </a:solidFill>
@@ -3783,10 +3876,10 @@
       </p:sp>
       <p:sp>
         <p:nvSpPr>
-          <p:cNvPr id="3" name="">
+          <p:cNvPr id="4" name="">
             <a:extLst xmlns:a="http://schemas.openxmlformats.org/drawingml/2006/main">
               <a:ext uri="{FF2B5EF4-FFF2-40B4-BE49-F238E27FC236}">
-                <a16:creationId xmlns:a16="http://schemas.microsoft.com/office/drawing/2014/main" id="{6D7458CB-B9A9-44F5-AB92-F86FBA4B90B5}"/>
+                <a16:creationId xmlns:a16="http://schemas.microsoft.com/office/drawing/2014/main" id="{6CFA27CA-2002-428E-9114-CDDBF17136C9}"/>
               </a:ext>
             </a:extLst>
           </p:cNvPr>
@@ -3848,17 +3941,17 @@
                 <a:ea typeface="Lato"/>
                 <a:cs typeface="Lato"/>
               </a:rPr>
-              <a:t>Innovations ICT · internal walkthrough</a:t>
+              <a:t>Innovations ICT · how the app works today</a:t>
             </a:r>
           </a:p>
         </p:txBody>
       </p:sp>
       <p:pic>
         <p:nvPicPr>
-          <p:cNvPr id="4" name="">
+          <p:cNvPr id="5" name="">
             <a:extLst xmlns:a="http://schemas.openxmlformats.org/drawingml/2006/main">
               <a:ext uri="{FF2B5EF4-FFF2-40B4-BE49-F238E27FC236}">
-                <a16:creationId xmlns:a16="http://schemas.microsoft.com/office/drawing/2014/main" id="{38DB3F56-A37E-4408-A45B-0FB6FB10F9D8}"/>
+                <a16:creationId xmlns:a16="http://schemas.microsoft.com/office/drawing/2014/main" id="{56EE7094-BD35-4124-B1D4-2389A86DA7CB}"/>
               </a:ext>
             </a:extLst>
           </p:cNvPr>
@@ -3868,17 +3961,17 @@
           <p:nvPr/>
         </p:nvPicPr>
         <p:blipFill>
-          <a:blip xmlns:r="http://schemas.openxmlformats.org/officeDocument/2006/relationships" xmlns:a="http://schemas.openxmlformats.org/drawingml/2006/main" r:embed="Ra6403a77ffd84fe6"/>
+          <a:blip xmlns:r="http://schemas.openxmlformats.org/officeDocument/2006/relationships" xmlns:a="http://schemas.openxmlformats.org/drawingml/2006/main" r:embed="Rc23c093bd2184f6c"/>
           <a:stretch xmlns:a="http://schemas.openxmlformats.org/drawingml/2006/main"/>
         </p:blipFill>
         <p:spPr>
           <a:xfrm xmlns:a="http://schemas.openxmlformats.org/drawingml/2006/main">
-            <a:off x="8382000" y="575163"/>
-            <a:ext cx="2857500" cy="6183923"/>
+            <a:off x="5715000" y="1763316"/>
+            <a:ext cx="5905500" cy="3321844"/>
           </a:xfrm>
           <a:prstGeom xmlns:a="http://schemas.openxmlformats.org/drawingml/2006/main" prst="roundRect">
             <a:avLst>
-              <a:gd name="adj" fmla="val 5333"/>
+              <a:gd name="adj" fmla="val 4585"/>
             </a:avLst>
           </a:prstGeom>
         </p:spPr>
@@ -3886,7 +3979,7 @@
     </p:spTree>
     <p:extLst>
       <p:ext uri="{BB962C8B-B14F-4D97-AF65-F5344CB8AC3E}">
-        <p14:creationId xmlns:p14="http://schemas.microsoft.com/office/powerpoint/2010/main" val="693070150"/>
+        <p14:creationId xmlns:p14="http://schemas.microsoft.com/office/powerpoint/2010/main" val="905640932"/>
       </p:ext>
     </p:extLst>
   </p:cSld>
@@ -3917,7 +4010,7 @@
           <p:cNvPr id="4" name="">
             <a:extLst xmlns:a="http://schemas.openxmlformats.org/drawingml/2006/main">
               <a:ext uri="{FF2B5EF4-FFF2-40B4-BE49-F238E27FC236}">
-                <a16:creationId xmlns:a16="http://schemas.microsoft.com/office/drawing/2014/main" id="{BE510CFC-387E-497B-8FD2-3D2936B8E2A7}"/>
+                <a16:creationId xmlns:a16="http://schemas.microsoft.com/office/drawing/2014/main" id="{6F8C7BD3-0DEB-40FB-ACA1-5F2D34DF2F2E}"/>
               </a:ext>
             </a:extLst>
           </p:cNvPr>
@@ -3928,8 +4021,8 @@
         </p:nvSpPr>
         <p:spPr>
           <a:xfrm xmlns:a="http://schemas.openxmlformats.org/drawingml/2006/main">
-            <a:off x="685800" y="514350"/>
-            <a:ext cx="8572500" cy="457200"/>
+            <a:off x="685800" y="457200"/>
+            <a:ext cx="9525000" cy="438150"/>
           </a:xfrm>
           <a:prstGeom xmlns:a="http://schemas.openxmlformats.org/drawingml/2006/main" prst="rect">
             <a:avLst/>
@@ -3945,7 +4038,7 @@
           </a:bodyPr>
           <a:lstStyle xmlns:a="http://schemas.openxmlformats.org/drawingml/2006/main">
             <a:defPPr algn="l">
-              <a:defRPr sz="2700" b="1">
+              <a:defRPr sz="2550" b="1">
                 <a:solidFill>
                   <a:srgbClr val="12100F"/>
                 </a:solidFill>
@@ -3961,7 +4054,7 @@
                 <a:spcPct val="115000"/>
               </a:lnSpc>
               <a:buNone/>
-              <a:defRPr sz="2700" b="1">
+              <a:defRPr sz="2550" b="1">
                 <a:solidFill>
                   <a:srgbClr val="12100F"/>
                 </a:solidFill>
@@ -3971,7 +4064,7 @@
               </a:defRPr>
             </a:pPr>
             <a:r>
-              <a:rPr sz="2700" b="1">
+              <a:rPr sz="2550" b="1">
                 <a:solidFill>
                   <a:srgbClr val="12100F"/>
                 </a:solidFill>
@@ -3989,7 +4082,7 @@
           <p:cNvPr id="2" name="">
             <a:extLst xmlns:a="http://schemas.openxmlformats.org/drawingml/2006/main">
               <a:ext uri="{FF2B5EF4-FFF2-40B4-BE49-F238E27FC236}">
-                <a16:creationId xmlns:a16="http://schemas.microsoft.com/office/drawing/2014/main" id="{E77F0082-1695-4D8D-92D7-E12342DB23C8}"/>
+                <a16:creationId xmlns:a16="http://schemas.microsoft.com/office/drawing/2014/main" id="{55FD12FF-6922-404E-84A7-09BB5C206E4A}"/>
               </a:ext>
             </a:extLst>
           </p:cNvPr>
@@ -4000,8 +4093,8 @@
         </p:nvSpPr>
         <p:spPr>
           <a:xfrm xmlns:a="http://schemas.openxmlformats.org/drawingml/2006/main">
-            <a:off x="685800" y="1009650"/>
-            <a:ext cx="9906000" cy="571500"/>
+            <a:off x="685800" y="933450"/>
+            <a:ext cx="10096500" cy="533400"/>
           </a:xfrm>
           <a:prstGeom xmlns:a="http://schemas.openxmlformats.org/drawingml/2006/main" prst="rect">
             <a:avLst/>
@@ -4017,7 +4110,7 @@
           </a:bodyPr>
           <a:lstStyle xmlns:a="http://schemas.openxmlformats.org/drawingml/2006/main">
             <a:defPPr algn="l">
-              <a:defRPr sz="1425" b="0">
+              <a:defRPr sz="1350" b="0">
                 <a:solidFill>
                   <a:srgbClr val="6B6762"/>
                 </a:solidFill>
@@ -4033,7 +4126,7 @@
                 <a:spcPct val="115000"/>
               </a:lnSpc>
               <a:buNone/>
-              <a:defRPr sz="1425" b="0">
+              <a:defRPr sz="1350" b="0">
                 <a:solidFill>
                   <a:srgbClr val="6B6762"/>
                 </a:solidFill>
@@ -4043,7 +4136,7 @@
               </a:defRPr>
             </a:pPr>
             <a:r>
-              <a:rPr sz="1425" b="0">
+              <a:rPr sz="1350" b="0">
                 <a:solidFill>
                   <a:srgbClr val="6B6762"/>
                 </a:solidFill>
@@ -4061,7 +4154,7 @@
           <p:cNvPr id="3" name="">
             <a:extLst xmlns:a="http://schemas.openxmlformats.org/drawingml/2006/main">
               <a:ext uri="{FF2B5EF4-FFF2-40B4-BE49-F238E27FC236}">
-                <a16:creationId xmlns:a16="http://schemas.microsoft.com/office/drawing/2014/main" id="{39196429-47F3-4A9E-BFEE-B2CCAA74AD10}"/>
+                <a16:creationId xmlns:a16="http://schemas.microsoft.com/office/drawing/2014/main" id="{F60FF268-798F-431E-AA96-F82BFDD5D34E}"/>
               </a:ext>
             </a:extLst>
           </p:cNvPr>
@@ -4071,7 +4164,7 @@
           <p:nvPr/>
         </p:nvPicPr>
         <p:blipFill>
-          <a:blip xmlns:r="http://schemas.openxmlformats.org/officeDocument/2006/relationships" xmlns:a="http://schemas.openxmlformats.org/drawingml/2006/main" r:embed="R02cc7d19ef2a48f1"/>
+          <a:blip xmlns:r="http://schemas.openxmlformats.org/officeDocument/2006/relationships" xmlns:a="http://schemas.openxmlformats.org/drawingml/2006/main" r:embed="R8f6e2872a9eb4fac"/>
           <a:stretch xmlns:a="http://schemas.openxmlformats.org/drawingml/2006/main"/>
         </p:blipFill>
         <p:spPr>
@@ -4089,7 +4182,7 @@
     </p:spTree>
     <p:extLst>
       <p:ext uri="{BB962C8B-B14F-4D97-AF65-F5344CB8AC3E}">
-        <p14:creationId xmlns:p14="http://schemas.microsoft.com/office/powerpoint/2010/main" val="133004762"/>
+        <p14:creationId xmlns:p14="http://schemas.microsoft.com/office/powerpoint/2010/main" val="2016965280"/>
       </p:ext>
     </p:extLst>
   </p:cSld>
@@ -4120,7 +4213,7 @@
           <p:cNvPr id="4" name="">
             <a:extLst xmlns:a="http://schemas.openxmlformats.org/drawingml/2006/main">
               <a:ext uri="{FF2B5EF4-FFF2-40B4-BE49-F238E27FC236}">
-                <a16:creationId xmlns:a16="http://schemas.microsoft.com/office/drawing/2014/main" id="{83B9F417-2BF2-451F-87B3-AF87C14A3913}"/>
+                <a16:creationId xmlns:a16="http://schemas.microsoft.com/office/drawing/2014/main" id="{F2100139-D109-41A6-A9F0-58A65B27C9C7}"/>
               </a:ext>
             </a:extLst>
           </p:cNvPr>
@@ -4131,8 +4224,8 @@
         </p:nvSpPr>
         <p:spPr>
           <a:xfrm xmlns:a="http://schemas.openxmlformats.org/drawingml/2006/main">
-            <a:off x="685800" y="514350"/>
-            <a:ext cx="8572500" cy="457200"/>
+            <a:off x="685800" y="457200"/>
+            <a:ext cx="9525000" cy="438150"/>
           </a:xfrm>
           <a:prstGeom xmlns:a="http://schemas.openxmlformats.org/drawingml/2006/main" prst="rect">
             <a:avLst/>
@@ -4148,7 +4241,7 @@
           </a:bodyPr>
           <a:lstStyle xmlns:a="http://schemas.openxmlformats.org/drawingml/2006/main">
             <a:defPPr algn="l">
-              <a:defRPr sz="2700" b="1">
+              <a:defRPr sz="2550" b="1">
                 <a:solidFill>
                   <a:srgbClr val="12100F"/>
                 </a:solidFill>
@@ -4164,7 +4257,7 @@
                 <a:spcPct val="115000"/>
               </a:lnSpc>
               <a:buNone/>
-              <a:defRPr sz="2700" b="1">
+              <a:defRPr sz="2550" b="1">
                 <a:solidFill>
                   <a:srgbClr val="12100F"/>
                 </a:solidFill>
@@ -4174,7 +4267,7 @@
               </a:defRPr>
             </a:pPr>
             <a:r>
-              <a:rPr sz="2700" b="1">
+              <a:rPr sz="2550" b="1">
                 <a:solidFill>
                   <a:srgbClr val="12100F"/>
                 </a:solidFill>
@@ -4192,7 +4285,7 @@
           <p:cNvPr id="2" name="">
             <a:extLst xmlns:a="http://schemas.openxmlformats.org/drawingml/2006/main">
               <a:ext uri="{FF2B5EF4-FFF2-40B4-BE49-F238E27FC236}">
-                <a16:creationId xmlns:a16="http://schemas.microsoft.com/office/drawing/2014/main" id="{CEF3A43A-4F77-4ED8-B9F9-EBBF29851ABE}"/>
+                <a16:creationId xmlns:a16="http://schemas.microsoft.com/office/drawing/2014/main" id="{AEC91BAA-73DA-42B5-B5B2-15A9C8258C1A}"/>
               </a:ext>
             </a:extLst>
           </p:cNvPr>
@@ -4203,8 +4296,8 @@
         </p:nvSpPr>
         <p:spPr>
           <a:xfrm xmlns:a="http://schemas.openxmlformats.org/drawingml/2006/main">
-            <a:off x="685800" y="1009650"/>
-            <a:ext cx="9906000" cy="571500"/>
+            <a:off x="685800" y="933450"/>
+            <a:ext cx="10096500" cy="533400"/>
           </a:xfrm>
           <a:prstGeom xmlns:a="http://schemas.openxmlformats.org/drawingml/2006/main" prst="rect">
             <a:avLst/>
@@ -4220,7 +4313,7 @@
           </a:bodyPr>
           <a:lstStyle xmlns:a="http://schemas.openxmlformats.org/drawingml/2006/main">
             <a:defPPr algn="l">
-              <a:defRPr sz="1425" b="0">
+              <a:defRPr sz="1350" b="0">
                 <a:solidFill>
                   <a:srgbClr val="6B6762"/>
                 </a:solidFill>
@@ -4236,7 +4329,7 @@
                 <a:spcPct val="115000"/>
               </a:lnSpc>
               <a:buNone/>
-              <a:defRPr sz="1425" b="0">
+              <a:defRPr sz="1350" b="0">
                 <a:solidFill>
                   <a:srgbClr val="6B6762"/>
                 </a:solidFill>
@@ -4246,7 +4339,7 @@
               </a:defRPr>
             </a:pPr>
             <a:r>
-              <a:rPr sz="1425" b="0">
+              <a:rPr sz="1350" b="0">
                 <a:solidFill>
                   <a:srgbClr val="6B6762"/>
                 </a:solidFill>
@@ -4264,7 +4357,7 @@
           <p:cNvPr id="3" name="">
             <a:extLst xmlns:a="http://schemas.openxmlformats.org/drawingml/2006/main">
               <a:ext uri="{FF2B5EF4-FFF2-40B4-BE49-F238E27FC236}">
-                <a16:creationId xmlns:a16="http://schemas.microsoft.com/office/drawing/2014/main" id="{99BB9B0F-E600-4546-B5E7-0A8ED4E157F2}"/>
+                <a16:creationId xmlns:a16="http://schemas.microsoft.com/office/drawing/2014/main" id="{CA294AFB-1FCD-4322-B876-5EEA1A8F7373}"/>
               </a:ext>
             </a:extLst>
           </p:cNvPr>
@@ -4274,7 +4367,7 @@
           <p:nvPr/>
         </p:nvPicPr>
         <p:blipFill>
-          <a:blip xmlns:r="http://schemas.openxmlformats.org/officeDocument/2006/relationships" xmlns:a="http://schemas.openxmlformats.org/drawingml/2006/main" r:embed="R66dc50c8d0fb4d9f"/>
+          <a:blip xmlns:r="http://schemas.openxmlformats.org/officeDocument/2006/relationships" xmlns:a="http://schemas.openxmlformats.org/drawingml/2006/main" r:embed="Rc0cd18d50a794ae1"/>
           <a:stretch xmlns:a="http://schemas.openxmlformats.org/drawingml/2006/main"/>
         </p:blipFill>
         <p:spPr>
@@ -4292,7 +4385,7 @@
     </p:spTree>
     <p:extLst>
       <p:ext uri="{BB962C8B-B14F-4D97-AF65-F5344CB8AC3E}">
-        <p14:creationId xmlns:p14="http://schemas.microsoft.com/office/powerpoint/2010/main" val="1291463241"/>
+        <p14:creationId xmlns:p14="http://schemas.microsoft.com/office/powerpoint/2010/main" val="1016214143"/>
       </p:ext>
     </p:extLst>
   </p:cSld>
@@ -4323,7 +4416,7 @@
           <p:cNvPr id="4" name="">
             <a:extLst xmlns:a="http://schemas.openxmlformats.org/drawingml/2006/main">
               <a:ext uri="{FF2B5EF4-FFF2-40B4-BE49-F238E27FC236}">
-                <a16:creationId xmlns:a16="http://schemas.microsoft.com/office/drawing/2014/main" id="{D72D493E-A35B-42D7-A08A-DB89906C14EA}"/>
+                <a16:creationId xmlns:a16="http://schemas.microsoft.com/office/drawing/2014/main" id="{63132F04-434B-4FFA-B605-9D3BA2820711}"/>
               </a:ext>
             </a:extLst>
           </p:cNvPr>
@@ -4334,8 +4427,8 @@
         </p:nvSpPr>
         <p:spPr>
           <a:xfrm xmlns:a="http://schemas.openxmlformats.org/drawingml/2006/main">
-            <a:off x="685800" y="514350"/>
-            <a:ext cx="8572500" cy="457200"/>
+            <a:off x="685800" y="457200"/>
+            <a:ext cx="9525000" cy="438150"/>
           </a:xfrm>
           <a:prstGeom xmlns:a="http://schemas.openxmlformats.org/drawingml/2006/main" prst="rect">
             <a:avLst/>
@@ -4351,7 +4444,7 @@
           </a:bodyPr>
           <a:lstStyle xmlns:a="http://schemas.openxmlformats.org/drawingml/2006/main">
             <a:defPPr algn="l">
-              <a:defRPr sz="2700" b="1">
+              <a:defRPr sz="2550" b="1">
                 <a:solidFill>
                   <a:srgbClr val="12100F"/>
                 </a:solidFill>
@@ -4367,7 +4460,7 @@
                 <a:spcPct val="115000"/>
               </a:lnSpc>
               <a:buNone/>
-              <a:defRPr sz="2700" b="1">
+              <a:defRPr sz="2550" b="1">
                 <a:solidFill>
                   <a:srgbClr val="12100F"/>
                 </a:solidFill>
@@ -4377,7 +4470,7 @@
               </a:defRPr>
             </a:pPr>
             <a:r>
-              <a:rPr sz="2700" b="1">
+              <a:rPr sz="2550" b="1">
                 <a:solidFill>
                   <a:srgbClr val="12100F"/>
                 </a:solidFill>
@@ -4385,7 +4478,7 @@
                 <a:ea typeface="Lato"/>
                 <a:cs typeface="Lato"/>
               </a:rPr>
-              <a:t>Bragging rights</a:t>
+              <a:t>That's a wrap</a:t>
             </a:r>
           </a:p>
         </p:txBody>
@@ -4395,7 +4488,7 @@
           <p:cNvPr id="2" name="">
             <a:extLst xmlns:a="http://schemas.openxmlformats.org/drawingml/2006/main">
               <a:ext uri="{FF2B5EF4-FFF2-40B4-BE49-F238E27FC236}">
-                <a16:creationId xmlns:a16="http://schemas.microsoft.com/office/drawing/2014/main" id="{0DB8958E-AE1D-4922-A7F0-729805FC864A}"/>
+                <a16:creationId xmlns:a16="http://schemas.microsoft.com/office/drawing/2014/main" id="{7FBB4D0F-5D42-4C4A-B049-9D4EF26321C8}"/>
               </a:ext>
             </a:extLst>
           </p:cNvPr>
@@ -4406,8 +4499,8 @@
         </p:nvSpPr>
         <p:spPr>
           <a:xfrm xmlns:a="http://schemas.openxmlformats.org/drawingml/2006/main">
-            <a:off x="685800" y="1009650"/>
-            <a:ext cx="9906000" cy="571500"/>
+            <a:off x="685800" y="933450"/>
+            <a:ext cx="10096500" cy="533400"/>
           </a:xfrm>
           <a:prstGeom xmlns:a="http://schemas.openxmlformats.org/drawingml/2006/main" prst="rect">
             <a:avLst/>
@@ -4423,7 +4516,7 @@
           </a:bodyPr>
           <a:lstStyle xmlns:a="http://schemas.openxmlformats.org/drawingml/2006/main">
             <a:defPPr algn="l">
-              <a:defRPr sz="1425" b="0">
+              <a:defRPr sz="1350" b="0">
                 <a:solidFill>
                   <a:srgbClr val="6B6762"/>
                 </a:solidFill>
@@ -4439,7 +4532,7 @@
                 <a:spcPct val="115000"/>
               </a:lnSpc>
               <a:buNone/>
-              <a:defRPr sz="1425" b="0">
+              <a:defRPr sz="1350" b="0">
                 <a:solidFill>
                   <a:srgbClr val="6B6762"/>
                 </a:solidFill>
@@ -4449,7 +4542,7 @@
               </a:defRPr>
             </a:pPr>
             <a:r>
-              <a:rPr sz="1425" b="0">
+              <a:rPr sz="1350" b="0">
                 <a:solidFill>
                   <a:srgbClr val="6B6762"/>
                 </a:solidFill>
@@ -4457,7 +4550,7 @@
                 <a:ea typeface="Lato"/>
                 <a:cs typeface="Lato"/>
               </a:rPr>
-              <a:t>XP for playing, proposing and finishing work. It is for fun, never a performance measure.</a:t>
+              <a:t>The meeting closes with what it produced, and everybody is released back to normal Mshikaki.</a:t>
             </a:r>
           </a:p>
         </p:txBody>
@@ -4467,7 +4560,7 @@
           <p:cNvPr id="3" name="">
             <a:extLst xmlns:a="http://schemas.openxmlformats.org/drawingml/2006/main">
               <a:ext uri="{FF2B5EF4-FFF2-40B4-BE49-F238E27FC236}">
-                <a16:creationId xmlns:a16="http://schemas.microsoft.com/office/drawing/2014/main" id="{C1135CF0-1E76-4039-9AE1-39D44BAB5061}"/>
+                <a16:creationId xmlns:a16="http://schemas.microsoft.com/office/drawing/2014/main" id="{74EE1BFA-A6D3-4521-B09C-259499F59455}"/>
               </a:ext>
             </a:extLst>
           </p:cNvPr>
@@ -4477,7 +4570,7 @@
           <p:nvPr/>
         </p:nvPicPr>
         <p:blipFill>
-          <a:blip xmlns:r="http://schemas.openxmlformats.org/officeDocument/2006/relationships" xmlns:a="http://schemas.openxmlformats.org/drawingml/2006/main" r:embed="Rc73b1fdf4245462b"/>
+          <a:blip xmlns:r="http://schemas.openxmlformats.org/officeDocument/2006/relationships" xmlns:a="http://schemas.openxmlformats.org/drawingml/2006/main" r:embed="Rf4602ae581584133"/>
           <a:stretch xmlns:a="http://schemas.openxmlformats.org/drawingml/2006/main"/>
         </p:blipFill>
         <p:spPr>
@@ -4495,7 +4588,7 @@
     </p:spTree>
     <p:extLst>
       <p:ext uri="{BB962C8B-B14F-4D97-AF65-F5344CB8AC3E}">
-        <p14:creationId xmlns:p14="http://schemas.microsoft.com/office/powerpoint/2010/main" val="536483241"/>
+        <p14:creationId xmlns:p14="http://schemas.microsoft.com/office/powerpoint/2010/main" val="1586037811"/>
       </p:ext>
     </p:extLst>
   </p:cSld>
@@ -4526,7 +4619,7 @@
           <p:cNvPr id="5" name="">
             <a:extLst xmlns:a="http://schemas.openxmlformats.org/drawingml/2006/main">
               <a:ext uri="{FF2B5EF4-FFF2-40B4-BE49-F238E27FC236}">
-                <a16:creationId xmlns:a16="http://schemas.microsoft.com/office/drawing/2014/main" id="{A5733C98-76F4-4831-BD3A-B9A9370B1B8B}"/>
+                <a16:creationId xmlns:a16="http://schemas.microsoft.com/office/drawing/2014/main" id="{91A1D99D-7B40-4C23-8229-08E3557D08AA}"/>
               </a:ext>
             </a:extLst>
           </p:cNvPr>
@@ -4537,8 +4630,8 @@
         </p:nvSpPr>
         <p:spPr>
           <a:xfrm xmlns:a="http://schemas.openxmlformats.org/drawingml/2006/main">
-            <a:off x="685800" y="514350"/>
-            <a:ext cx="8572500" cy="457200"/>
+            <a:off x="685800" y="457200"/>
+            <a:ext cx="9525000" cy="438150"/>
           </a:xfrm>
           <a:prstGeom xmlns:a="http://schemas.openxmlformats.org/drawingml/2006/main" prst="rect">
             <a:avLst/>
@@ -4554,7 +4647,7 @@
           </a:bodyPr>
           <a:lstStyle xmlns:a="http://schemas.openxmlformats.org/drawingml/2006/main">
             <a:defPPr algn="l">
-              <a:defRPr sz="2700" b="1">
+              <a:defRPr sz="2550" b="1">
                 <a:solidFill>
                   <a:srgbClr val="12100F"/>
                 </a:solidFill>
@@ -4570,7 +4663,7 @@
                 <a:spcPct val="115000"/>
               </a:lnSpc>
               <a:buNone/>
-              <a:defRPr sz="2700" b="1">
+              <a:defRPr sz="2550" b="1">
                 <a:solidFill>
                   <a:srgbClr val="12100F"/>
                 </a:solidFill>
@@ -4580,7 +4673,7 @@
               </a:defRPr>
             </a:pPr>
             <a:r>
-              <a:rPr sz="2700" b="1">
+              <a:rPr sz="2550" b="1">
                 <a:solidFill>
                   <a:srgbClr val="12100F"/>
                 </a:solidFill>
@@ -4588,7 +4681,7 @@
                 <a:ea typeface="Lato"/>
                 <a:cs typeface="Lato"/>
               </a:rPr>
-              <a:t>That's a wrap</a:t>
+              <a:t>The minutes write themselves</a:t>
             </a:r>
           </a:p>
         </p:txBody>
@@ -4598,7 +4691,7 @@
           <p:cNvPr id="2" name="">
             <a:extLst xmlns:a="http://schemas.openxmlformats.org/drawingml/2006/main">
               <a:ext uri="{FF2B5EF4-FFF2-40B4-BE49-F238E27FC236}">
-                <a16:creationId xmlns:a16="http://schemas.microsoft.com/office/drawing/2014/main" id="{4C70C54C-1B92-4EA2-A401-C3891572A470}"/>
+                <a16:creationId xmlns:a16="http://schemas.microsoft.com/office/drawing/2014/main" id="{A42BECBF-FA22-4DF1-BA0E-DD72E72C493A}"/>
               </a:ext>
             </a:extLst>
           </p:cNvPr>
@@ -4609,8 +4702,8 @@
         </p:nvSpPr>
         <p:spPr>
           <a:xfrm xmlns:a="http://schemas.openxmlformats.org/drawingml/2006/main">
-            <a:off x="685800" y="1009650"/>
-            <a:ext cx="9906000" cy="571500"/>
+            <a:off x="685800" y="933450"/>
+            <a:ext cx="10096500" cy="533400"/>
           </a:xfrm>
           <a:prstGeom xmlns:a="http://schemas.openxmlformats.org/drawingml/2006/main" prst="rect">
             <a:avLst/>
@@ -4626,7 +4719,7 @@
           </a:bodyPr>
           <a:lstStyle xmlns:a="http://schemas.openxmlformats.org/drawingml/2006/main">
             <a:defPPr algn="l">
-              <a:defRPr sz="1425" b="0">
+              <a:defRPr sz="1350" b="0">
                 <a:solidFill>
                   <a:srgbClr val="6B6762"/>
                 </a:solidFill>
@@ -4642,7 +4735,7 @@
                 <a:spcPct val="115000"/>
               </a:lnSpc>
               <a:buNone/>
-              <a:defRPr sz="1425" b="0">
+              <a:defRPr sz="1350" b="0">
                 <a:solidFill>
                   <a:srgbClr val="6B6762"/>
                 </a:solidFill>
@@ -4652,7 +4745,7 @@
               </a:defRPr>
             </a:pPr>
             <a:r>
-              <a:rPr sz="1425" b="0">
+              <a:rPr sz="1350" b="0">
                 <a:solidFill>
                   <a:srgbClr val="6B6762"/>
                 </a:solidFill>
@@ -4660,7 +4753,7 @@
                 <a:ea typeface="Lato"/>
                 <a:cs typeface="Lato"/>
               </a:rPr>
-              <a:t>The meeting closes, the summary writes itself, and everybody goes back to normal Mshikaki. Open the app, press Let's play, and let the room scan the code.</a:t>
+              <a:t>One frozen snapshot, three ways to share it: HTML in the browser, plain text for WhatsApp, and a printable PDF.</a:t>
             </a:r>
           </a:p>
         </p:txBody>
@@ -4670,7 +4763,7 @@
           <p:cNvPr id="3" name="">
             <a:extLst xmlns:a="http://schemas.openxmlformats.org/drawingml/2006/main">
               <a:ext uri="{FF2B5EF4-FFF2-40B4-BE49-F238E27FC236}">
-                <a16:creationId xmlns:a16="http://schemas.microsoft.com/office/drawing/2014/main" id="{BAA0B0DA-86B3-4C6B-92E6-BDA93E5AD293}"/>
+                <a16:creationId xmlns:a16="http://schemas.microsoft.com/office/drawing/2014/main" id="{656FF3C5-74D8-463A-9FB9-47A2EA506A9C}"/>
               </a:ext>
             </a:extLst>
           </p:cNvPr>
@@ -4680,17 +4773,17 @@
           <p:nvPr/>
         </p:nvPicPr>
         <p:blipFill>
-          <a:blip xmlns:r="http://schemas.openxmlformats.org/officeDocument/2006/relationships" xmlns:a="http://schemas.openxmlformats.org/drawingml/2006/main" r:embed="Rcbc894ba4e444d1d"/>
+          <a:blip xmlns:r="http://schemas.openxmlformats.org/officeDocument/2006/relationships" xmlns:a="http://schemas.openxmlformats.org/drawingml/2006/main" r:embed="R5b6184fc6da445f5"/>
           <a:stretch xmlns:a="http://schemas.openxmlformats.org/drawingml/2006/main"/>
         </p:blipFill>
         <p:spPr>
           <a:xfrm xmlns:a="http://schemas.openxmlformats.org/drawingml/2006/main">
-            <a:off x="1048698" y="2000250"/>
-            <a:ext cx="2112654" cy="4572000"/>
+            <a:off x="685800" y="2383631"/>
+            <a:ext cx="5257800" cy="2957513"/>
           </a:xfrm>
           <a:prstGeom xmlns:a="http://schemas.openxmlformats.org/drawingml/2006/main" prst="roundRect">
             <a:avLst>
-              <a:gd name="adj" fmla="val 5405"/>
+              <a:gd name="adj" fmla="val 3859"/>
             </a:avLst>
           </a:prstGeom>
         </p:spPr>
@@ -4700,7 +4793,7 @@
           <p:cNvPr id="4" name="">
             <a:extLst xmlns:a="http://schemas.openxmlformats.org/drawingml/2006/main">
               <a:ext uri="{FF2B5EF4-FFF2-40B4-BE49-F238E27FC236}">
-                <a16:creationId xmlns:a16="http://schemas.microsoft.com/office/drawing/2014/main" id="{8E9F42C5-7A83-4069-8A7A-FC94C64D37EE}"/>
+                <a16:creationId xmlns:a16="http://schemas.microsoft.com/office/drawing/2014/main" id="{B01D7DB2-3BA6-4870-9B01-23D5543BD104}"/>
               </a:ext>
             </a:extLst>
           </p:cNvPr>
@@ -4710,17 +4803,17 @@
           <p:nvPr/>
         </p:nvPicPr>
         <p:blipFill>
-          <a:blip xmlns:r="http://schemas.openxmlformats.org/officeDocument/2006/relationships" xmlns:a="http://schemas.openxmlformats.org/drawingml/2006/main" r:embed="Rb4bee47a1d9a4de2"/>
+          <a:blip xmlns:r="http://schemas.openxmlformats.org/officeDocument/2006/relationships" xmlns:a="http://schemas.openxmlformats.org/drawingml/2006/main" r:embed="Rba8a72c8258f4b82"/>
           <a:stretch xmlns:a="http://schemas.openxmlformats.org/drawingml/2006/main"/>
         </p:blipFill>
         <p:spPr>
           <a:xfrm xmlns:a="http://schemas.openxmlformats.org/drawingml/2006/main">
-            <a:off x="3810000" y="2287191"/>
-            <a:ext cx="7734300" cy="4350544"/>
+            <a:off x="6572731" y="1809750"/>
+            <a:ext cx="3428038" cy="4848225"/>
           </a:xfrm>
           <a:prstGeom xmlns:a="http://schemas.openxmlformats.org/drawingml/2006/main" prst="roundRect">
             <a:avLst>
-              <a:gd name="adj" fmla="val 2626"/>
+              <a:gd name="adj" fmla="val 3333"/>
             </a:avLst>
           </a:prstGeom>
         </p:spPr>
@@ -4728,7 +4821,210 @@
     </p:spTree>
     <p:extLst>
       <p:ext uri="{BB962C8B-B14F-4D97-AF65-F5344CB8AC3E}">
-        <p14:creationId xmlns:p14="http://schemas.microsoft.com/office/powerpoint/2010/main" val="927093960"/>
+        <p14:creationId xmlns:p14="http://schemas.microsoft.com/office/powerpoint/2010/main" val="1772412182"/>
+      </p:ext>
+    </p:extLst>
+  </p:cSld>
+</p:sld>
+</file>
+
+<file path=ppt/slides/slide14.xml><?xml version="1.0" encoding="utf-8"?>
+<p:sld xmlns:p="http://schemas.openxmlformats.org/presentationml/2006/main">
+  <p:cSld>
+    <p:bg>
+      <p:bgPr>
+        <a:solidFill xmlns:a="http://schemas.openxmlformats.org/drawingml/2006/main">
+          <a:srgbClr val="FBF9F7"/>
+        </a:solidFill>
+      </p:bgPr>
+    </p:bg>
+    <p:spTree>
+      <p:nvGrpSpPr>
+        <p:cNvPr id="1" name=""/>
+        <p:cNvGrpSpPr/>
+        <p:nvPr/>
+      </p:nvGrpSpPr>
+      <p:grpSpPr>
+        <a:xfrm xmlns:a="http://schemas.openxmlformats.org/drawingml/2006/main"/>
+      </p:grpSpPr>
+      <p:sp>
+        <p:nvSpPr>
+          <p:cNvPr id="4" name="">
+            <a:extLst xmlns:a="http://schemas.openxmlformats.org/drawingml/2006/main">
+              <a:ext uri="{FF2B5EF4-FFF2-40B4-BE49-F238E27FC236}">
+                <a16:creationId xmlns:a16="http://schemas.microsoft.com/office/drawing/2014/main" id="{CCAE5DF5-F45C-46B3-A512-C108075E5576}"/>
+              </a:ext>
+            </a:extLst>
+          </p:cNvPr>
+          <p:cNvSpPr>
+            <a:spLocks xmlns:a="http://schemas.openxmlformats.org/drawingml/2006/main" noGrp="1"/>
+          </p:cNvSpPr>
+          <p:nvPr/>
+        </p:nvSpPr>
+        <p:spPr>
+          <a:xfrm xmlns:a="http://schemas.openxmlformats.org/drawingml/2006/main">
+            <a:off x="685800" y="457200"/>
+            <a:ext cx="9525000" cy="438150"/>
+          </a:xfrm>
+          <a:prstGeom xmlns:a="http://schemas.openxmlformats.org/drawingml/2006/main" prst="rect">
+            <a:avLst/>
+          </a:prstGeom>
+          <a:noFill xmlns:a="http://schemas.openxmlformats.org/drawingml/2006/main"/>
+          <a:ln xmlns:a="http://schemas.openxmlformats.org/drawingml/2006/main" w="0">
+            <a:noFill/>
+          </a:ln>
+        </p:spPr>
+        <p:txBody>
+          <a:bodyPr xmlns:a="http://schemas.openxmlformats.org/drawingml/2006/main">
+            <a:noAutofit/>
+          </a:bodyPr>
+          <a:lstStyle xmlns:a="http://schemas.openxmlformats.org/drawingml/2006/main">
+            <a:defPPr algn="l">
+              <a:defRPr sz="2550" b="1">
+                <a:solidFill>
+                  <a:srgbClr val="12100F"/>
+                </a:solidFill>
+                <a:latin typeface="Lato"/>
+                <a:ea typeface="Lato"/>
+                <a:cs typeface="Lato"/>
+              </a:defRPr>
+            </a:defPPr>
+          </a:lstStyle>
+          <a:p xmlns:a="http://schemas.openxmlformats.org/drawingml/2006/main">
+            <a:pPr algn="l">
+              <a:lnSpc>
+                <a:spcPct val="115000"/>
+              </a:lnSpc>
+              <a:buNone/>
+              <a:defRPr sz="2550" b="1">
+                <a:solidFill>
+                  <a:srgbClr val="12100F"/>
+                </a:solidFill>
+                <a:latin typeface="Lato"/>
+                <a:ea typeface="Lato"/>
+                <a:cs typeface="Lato"/>
+              </a:defRPr>
+            </a:pPr>
+            <a:r>
+              <a:rPr sz="2550" b="1">
+                <a:solidFill>
+                  <a:srgbClr val="12100F"/>
+                </a:solidFill>
+                <a:latin typeface="Lato"/>
+                <a:ea typeface="Lato"/>
+                <a:cs typeface="Lato"/>
+              </a:rPr>
+              <a:t>Bragging rights</a:t>
+            </a:r>
+          </a:p>
+        </p:txBody>
+      </p:sp>
+      <p:sp>
+        <p:nvSpPr>
+          <p:cNvPr id="2" name="">
+            <a:extLst xmlns:a="http://schemas.openxmlformats.org/drawingml/2006/main">
+              <a:ext uri="{FF2B5EF4-FFF2-40B4-BE49-F238E27FC236}">
+                <a16:creationId xmlns:a16="http://schemas.microsoft.com/office/drawing/2014/main" id="{DE2474C3-0187-46B3-B820-68E528FE5552}"/>
+              </a:ext>
+            </a:extLst>
+          </p:cNvPr>
+          <p:cNvSpPr>
+            <a:spLocks xmlns:a="http://schemas.openxmlformats.org/drawingml/2006/main" noGrp="1"/>
+          </p:cNvSpPr>
+          <p:nvPr/>
+        </p:nvSpPr>
+        <p:spPr>
+          <a:xfrm xmlns:a="http://schemas.openxmlformats.org/drawingml/2006/main">
+            <a:off x="685800" y="933450"/>
+            <a:ext cx="10096500" cy="533400"/>
+          </a:xfrm>
+          <a:prstGeom xmlns:a="http://schemas.openxmlformats.org/drawingml/2006/main" prst="rect">
+            <a:avLst/>
+          </a:prstGeom>
+          <a:noFill xmlns:a="http://schemas.openxmlformats.org/drawingml/2006/main"/>
+          <a:ln xmlns:a="http://schemas.openxmlformats.org/drawingml/2006/main" w="0">
+            <a:noFill/>
+          </a:ln>
+        </p:spPr>
+        <p:txBody>
+          <a:bodyPr xmlns:a="http://schemas.openxmlformats.org/drawingml/2006/main">
+            <a:noAutofit/>
+          </a:bodyPr>
+          <a:lstStyle xmlns:a="http://schemas.openxmlformats.org/drawingml/2006/main">
+            <a:defPPr algn="l">
+              <a:defRPr sz="1350" b="0">
+                <a:solidFill>
+                  <a:srgbClr val="6B6762"/>
+                </a:solidFill>
+                <a:latin typeface="Lato"/>
+                <a:ea typeface="Lato"/>
+                <a:cs typeface="Lato"/>
+              </a:defRPr>
+            </a:defPPr>
+          </a:lstStyle>
+          <a:p xmlns:a="http://schemas.openxmlformats.org/drawingml/2006/main">
+            <a:pPr algn="l">
+              <a:lnSpc>
+                <a:spcPct val="115000"/>
+              </a:lnSpc>
+              <a:buNone/>
+              <a:defRPr sz="1350" b="0">
+                <a:solidFill>
+                  <a:srgbClr val="6B6762"/>
+                </a:solidFill>
+                <a:latin typeface="Lato"/>
+                <a:ea typeface="Lato"/>
+                <a:cs typeface="Lato"/>
+              </a:defRPr>
+            </a:pPr>
+            <a:r>
+              <a:rPr sz="1350" b="0">
+                <a:solidFill>
+                  <a:srgbClr val="6B6762"/>
+                </a:solidFill>
+                <a:latin typeface="Lato"/>
+                <a:ea typeface="Lato"/>
+                <a:cs typeface="Lato"/>
+              </a:rPr>
+              <a:t>XP for playing, proposing and finishing work. It is for fun, never a performance measure.</a:t>
+            </a:r>
+          </a:p>
+        </p:txBody>
+      </p:sp>
+      <p:pic>
+        <p:nvPicPr>
+          <p:cNvPr id="3" name="">
+            <a:extLst xmlns:a="http://schemas.openxmlformats.org/drawingml/2006/main">
+              <a:ext uri="{FF2B5EF4-FFF2-40B4-BE49-F238E27FC236}">
+                <a16:creationId xmlns:a16="http://schemas.microsoft.com/office/drawing/2014/main" id="{7E787680-F0F5-426D-B44D-130EBC90495E}"/>
+              </a:ext>
+            </a:extLst>
+          </p:cNvPr>
+          <p:cNvPicPr>
+            <a:picLocks xmlns:a="http://schemas.openxmlformats.org/drawingml/2006/main" noChangeAspect="1"/>
+          </p:cNvPicPr>
+          <p:nvPr/>
+        </p:nvPicPr>
+        <p:blipFill>
+          <a:blip xmlns:r="http://schemas.openxmlformats.org/officeDocument/2006/relationships" xmlns:a="http://schemas.openxmlformats.org/drawingml/2006/main" r:embed="R795452ef04ad4d6e"/>
+          <a:stretch xmlns:a="http://schemas.openxmlformats.org/drawingml/2006/main"/>
+        </p:blipFill>
+        <p:spPr>
+          <a:xfrm xmlns:a="http://schemas.openxmlformats.org/drawingml/2006/main">
+            <a:off x="1811867" y="1866900"/>
+            <a:ext cx="8568267" cy="4819650"/>
+          </a:xfrm>
+          <a:prstGeom xmlns:a="http://schemas.openxmlformats.org/drawingml/2006/main" prst="roundRect">
+            <a:avLst>
+              <a:gd name="adj" fmla="val 2372"/>
+            </a:avLst>
+          </a:prstGeom>
+        </p:spPr>
+      </p:pic>
+    </p:spTree>
+    <p:extLst>
+      <p:ext uri="{BB962C8B-B14F-4D97-AF65-F5344CB8AC3E}">
+        <p14:creationId xmlns:p14="http://schemas.microsoft.com/office/powerpoint/2010/main" val="1022791191"/>
       </p:ext>
     </p:extLst>
   </p:cSld>
@@ -4759,7 +5055,7 @@
           <p:cNvPr id="19" name="">
             <a:extLst xmlns:a="http://schemas.openxmlformats.org/drawingml/2006/main">
               <a:ext uri="{FF2B5EF4-FFF2-40B4-BE49-F238E27FC236}">
-                <a16:creationId xmlns:a16="http://schemas.microsoft.com/office/drawing/2014/main" id="{F5797B76-3386-4A7E-9D7E-FED6B006FEA3}"/>
+                <a16:creationId xmlns:a16="http://schemas.microsoft.com/office/drawing/2014/main" id="{A8C2F319-A578-43C6-8F5E-32150C790A6D}"/>
               </a:ext>
             </a:extLst>
           </p:cNvPr>
@@ -4770,8 +5066,8 @@
         </p:nvSpPr>
         <p:spPr>
           <a:xfrm xmlns:a="http://schemas.openxmlformats.org/drawingml/2006/main">
-            <a:off x="685800" y="514350"/>
-            <a:ext cx="8572500" cy="457200"/>
+            <a:off x="685800" y="457200"/>
+            <a:ext cx="9525000" cy="438150"/>
           </a:xfrm>
           <a:prstGeom xmlns:a="http://schemas.openxmlformats.org/drawingml/2006/main" prst="rect">
             <a:avLst/>
@@ -4787,7 +5083,7 @@
           </a:bodyPr>
           <a:lstStyle xmlns:a="http://schemas.openxmlformats.org/drawingml/2006/main">
             <a:defPPr algn="l">
-              <a:defRPr sz="2700" b="1">
+              <a:defRPr sz="2550" b="1">
                 <a:solidFill>
                   <a:srgbClr val="12100F"/>
                 </a:solidFill>
@@ -4803,7 +5099,7 @@
                 <a:spcPct val="115000"/>
               </a:lnSpc>
               <a:buNone/>
-              <a:defRPr sz="2700" b="1">
+              <a:defRPr sz="2550" b="1">
                 <a:solidFill>
                   <a:srgbClr val="12100F"/>
                 </a:solidFill>
@@ -4813,7 +5109,7 @@
               </a:defRPr>
             </a:pPr>
             <a:r>
-              <a:rPr sz="2700" b="1">
+              <a:rPr sz="2550" b="1">
                 <a:solidFill>
                   <a:srgbClr val="12100F"/>
                 </a:solidFill>
@@ -4831,7 +5127,7 @@
           <p:cNvPr id="2" name="">
             <a:extLst xmlns:a="http://schemas.openxmlformats.org/drawingml/2006/main">
               <a:ext uri="{FF2B5EF4-FFF2-40B4-BE49-F238E27FC236}">
-                <a16:creationId xmlns:a16="http://schemas.microsoft.com/office/drawing/2014/main" id="{82B73DDC-D893-4FC7-8618-A4BF60C9461E}"/>
+                <a16:creationId xmlns:a16="http://schemas.microsoft.com/office/drawing/2014/main" id="{5232BC96-8D43-487E-B477-525D8DF959C9}"/>
               </a:ext>
             </a:extLst>
           </p:cNvPr>
@@ -4842,8 +5138,8 @@
         </p:nvSpPr>
         <p:spPr>
           <a:xfrm xmlns:a="http://schemas.openxmlformats.org/drawingml/2006/main">
-            <a:off x="685800" y="1009650"/>
-            <a:ext cx="9906000" cy="571500"/>
+            <a:off x="685800" y="933450"/>
+            <a:ext cx="10096500" cy="533400"/>
           </a:xfrm>
           <a:prstGeom xmlns:a="http://schemas.openxmlformats.org/drawingml/2006/main" prst="rect">
             <a:avLst/>
@@ -4859,7 +5155,7 @@
           </a:bodyPr>
           <a:lstStyle xmlns:a="http://schemas.openxmlformats.org/drawingml/2006/main">
             <a:defPPr algn="l">
-              <a:defRPr sz="1425" b="0">
+              <a:defRPr sz="1350" b="0">
                 <a:solidFill>
                   <a:srgbClr val="6B6762"/>
                 </a:solidFill>
@@ -4875,7 +5171,7 @@
                 <a:spcPct val="115000"/>
               </a:lnSpc>
               <a:buNone/>
-              <a:defRPr sz="1425" b="0">
+              <a:defRPr sz="1350" b="0">
                 <a:solidFill>
                   <a:srgbClr val="6B6762"/>
                 </a:solidFill>
@@ -4885,7 +5181,7 @@
               </a:defRPr>
             </a:pPr>
             <a:r>
-              <a:rPr sz="1425" b="0">
+              <a:rPr sz="1350" b="0">
                 <a:solidFill>
                   <a:srgbClr val="6B6762"/>
                 </a:solidFill>
@@ -4893,7 +5189,7 @@
                 <a:ea typeface="Lato"/>
                 <a:cs typeface="Lato"/>
               </a:rPr>
-              <a:t>One meeting moves through eight steps. The app never asks anybody to learn the words.</a:t>
+              <a:t>One meeting, from the first hello to the record it leaves behind.</a:t>
             </a:r>
           </a:p>
         </p:txBody>
@@ -4903,7 +5199,7 @@
           <p:cNvPr id="3" name="">
             <a:extLst xmlns:a="http://schemas.openxmlformats.org/drawingml/2006/main">
               <a:ext uri="{FF2B5EF4-FFF2-40B4-BE49-F238E27FC236}">
-                <a16:creationId xmlns:a16="http://schemas.microsoft.com/office/drawing/2014/main" id="{44F7F35A-2ACC-4332-8AFE-0CC440F5D150}"/>
+                <a16:creationId xmlns:a16="http://schemas.microsoft.com/office/drawing/2014/main" id="{B684817F-BCA9-4E03-B51C-1069D2A44283}"/>
               </a:ext>
             </a:extLst>
           </p:cNvPr>
@@ -4914,7 +5210,7 @@
         </p:nvSpPr>
         <p:spPr>
           <a:xfrm xmlns:a="http://schemas.openxmlformats.org/drawingml/2006/main">
-            <a:off x="685800" y="2381250"/>
+            <a:off x="685800" y="2190750"/>
             <a:ext cx="2476500" cy="1428750"/>
           </a:xfrm>
           <a:prstGeom xmlns:a="http://schemas.openxmlformats.org/drawingml/2006/main" prst="roundRect">
@@ -4937,7 +5233,7 @@
           </a:bodyPr>
           <a:lstStyle xmlns:a="http://schemas.openxmlformats.org/drawingml/2006/main">
             <a:defPPr>
-              <a:defRPr sz="1500" b="1">
+              <a:defRPr sz="1425" b="1">
                 <a:solidFill>
                   <a:srgbClr val="B3451F"/>
                 </a:solidFill>
@@ -4950,7 +5246,7 @@
           <a:p xmlns:a="http://schemas.openxmlformats.org/drawingml/2006/main">
             <a:pPr>
               <a:buNone/>
-              <a:defRPr sz="1500" b="1">
+              <a:defRPr sz="1425" b="1">
                 <a:solidFill>
                   <a:srgbClr val="B3451F"/>
                 </a:solidFill>
@@ -4960,7 +5256,7 @@
               </a:defRPr>
             </a:pPr>
             <a:r>
-              <a:rPr sz="1500" b="1">
+              <a:rPr sz="1425" b="1">
                 <a:solidFill>
                   <a:srgbClr val="B3451F"/>
                 </a:solidFill>
@@ -4968,7 +5264,7 @@
                 <a:ea typeface="Lato"/>
                 <a:cs typeface="Lato"/>
               </a:rPr>
-              <a:t>1  PLAY</a:t>
+              <a:t>1  JOIN</a:t>
             </a:r>
           </a:p>
         </p:txBody>
@@ -4978,7 +5274,7 @@
           <p:cNvPr id="4" name="">
             <a:extLst xmlns:a="http://schemas.openxmlformats.org/drawingml/2006/main">
               <a:ext uri="{FF2B5EF4-FFF2-40B4-BE49-F238E27FC236}">
-                <a16:creationId xmlns:a16="http://schemas.microsoft.com/office/drawing/2014/main" id="{5ED32DE4-D089-481D-B15C-D84ECF0EC078}"/>
+                <a16:creationId xmlns:a16="http://schemas.microsoft.com/office/drawing/2014/main" id="{61BBE1F7-98C0-4BFF-B77F-FF5847155B34}"/>
               </a:ext>
             </a:extLst>
           </p:cNvPr>
@@ -4989,8 +5285,8 @@
         </p:nvSpPr>
         <p:spPr>
           <a:xfrm xmlns:a="http://schemas.openxmlformats.org/drawingml/2006/main">
-            <a:off x="876300" y="3009900"/>
-            <a:ext cx="2095500" cy="571500"/>
+            <a:off x="876300" y="2781300"/>
+            <a:ext cx="2095500" cy="666750"/>
           </a:xfrm>
           <a:prstGeom xmlns:a="http://schemas.openxmlformats.org/drawingml/2006/main" prst="rect">
             <a:avLst/>
@@ -5006,7 +5302,7 @@
           </a:bodyPr>
           <a:lstStyle xmlns:a="http://schemas.openxmlformats.org/drawingml/2006/main">
             <a:defPPr algn="l">
-              <a:defRPr sz="1275" b="0">
+              <a:defRPr sz="1200" b="0">
                 <a:solidFill>
                   <a:srgbClr val="6B6762"/>
                 </a:solidFill>
@@ -5022,7 +5318,7 @@
                 <a:spcPct val="115000"/>
               </a:lnSpc>
               <a:buNone/>
-              <a:defRPr sz="1275" b="0">
+              <a:defRPr sz="1200" b="0">
                 <a:solidFill>
                   <a:srgbClr val="6B6762"/>
                 </a:solidFill>
@@ -5032,7 +5328,7 @@
               </a:defRPr>
             </a:pPr>
             <a:r>
-              <a:rPr sz="1275" b="0">
+              <a:rPr sz="1200" b="0">
                 <a:solidFill>
                   <a:srgbClr val="6B6762"/>
                 </a:solidFill>
@@ -5040,7 +5336,7 @@
                 <a:ea typeface="Lato"/>
                 <a:cs typeface="Lato"/>
               </a:rPr>
-              <a:t>A game warms the room</a:t>
+              <a:t>Scan the code, or open the link</a:t>
             </a:r>
           </a:p>
         </p:txBody>
@@ -5050,7 +5346,7 @@
           <p:cNvPr id="5" name="">
             <a:extLst xmlns:a="http://schemas.openxmlformats.org/drawingml/2006/main">
               <a:ext uri="{FF2B5EF4-FFF2-40B4-BE49-F238E27FC236}">
-                <a16:creationId xmlns:a16="http://schemas.microsoft.com/office/drawing/2014/main" id="{5C698DAD-4AAA-4B7A-9C43-92294E73F92F}"/>
+                <a16:creationId xmlns:a16="http://schemas.microsoft.com/office/drawing/2014/main" id="{89D60153-C70A-4F36-8443-BBD959800C56}"/>
               </a:ext>
             </a:extLst>
           </p:cNvPr>
@@ -5061,7 +5357,7 @@
         </p:nvSpPr>
         <p:spPr>
           <a:xfrm xmlns:a="http://schemas.openxmlformats.org/drawingml/2006/main">
-            <a:off x="3448050" y="2381250"/>
+            <a:off x="3448050" y="2190750"/>
             <a:ext cx="2476500" cy="1428750"/>
           </a:xfrm>
           <a:prstGeom xmlns:a="http://schemas.openxmlformats.org/drawingml/2006/main" prst="roundRect">
@@ -5084,7 +5380,7 @@
           </a:bodyPr>
           <a:lstStyle xmlns:a="http://schemas.openxmlformats.org/drawingml/2006/main">
             <a:defPPr>
-              <a:defRPr sz="1500" b="1">
+              <a:defRPr sz="1425" b="1">
                 <a:solidFill>
                   <a:srgbClr val="0F766E"/>
                 </a:solidFill>
@@ -5097,7 +5393,7 @@
           <a:p xmlns:a="http://schemas.openxmlformats.org/drawingml/2006/main">
             <a:pPr>
               <a:buNone/>
-              <a:defRPr sz="1500" b="1">
+              <a:defRPr sz="1425" b="1">
                 <a:solidFill>
                   <a:srgbClr val="0F766E"/>
                 </a:solidFill>
@@ -5107,7 +5403,7 @@
               </a:defRPr>
             </a:pPr>
             <a:r>
-              <a:rPr sz="1500" b="1">
+              <a:rPr sz="1425" b="1">
                 <a:solidFill>
                   <a:srgbClr val="0F766E"/>
                 </a:solidFill>
@@ -5115,7 +5411,7 @@
                 <a:ea typeface="Lato"/>
                 <a:cs typeface="Lato"/>
               </a:rPr>
-              <a:t>2  CONNECT</a:t>
+              <a:t>2  PLAY OR START</a:t>
             </a:r>
           </a:p>
         </p:txBody>
@@ -5125,7 +5421,7 @@
           <p:cNvPr id="6" name="">
             <a:extLst xmlns:a="http://schemas.openxmlformats.org/drawingml/2006/main">
               <a:ext uri="{FF2B5EF4-FFF2-40B4-BE49-F238E27FC236}">
-                <a16:creationId xmlns:a16="http://schemas.microsoft.com/office/drawing/2014/main" id="{E7E4378E-AFDA-4450-B0C7-0BCB537FA554}"/>
+                <a16:creationId xmlns:a16="http://schemas.microsoft.com/office/drawing/2014/main" id="{D1991A0D-B1D2-482E-9D60-5516F45C83F2}"/>
               </a:ext>
             </a:extLst>
           </p:cNvPr>
@@ -5136,8 +5432,8 @@
         </p:nvSpPr>
         <p:spPr>
           <a:xfrm xmlns:a="http://schemas.openxmlformats.org/drawingml/2006/main">
-            <a:off x="3638550" y="3009900"/>
-            <a:ext cx="2095500" cy="571500"/>
+            <a:off x="3638550" y="2781300"/>
+            <a:ext cx="2095500" cy="666750"/>
           </a:xfrm>
           <a:prstGeom xmlns:a="http://schemas.openxmlformats.org/drawingml/2006/main" prst="rect">
             <a:avLst/>
@@ -5153,7 +5449,7 @@
           </a:bodyPr>
           <a:lstStyle xmlns:a="http://schemas.openxmlformats.org/drawingml/2006/main">
             <a:defPPr algn="l">
-              <a:defRPr sz="1275" b="0">
+              <a:defRPr sz="1200" b="0">
                 <a:solidFill>
                   <a:srgbClr val="6B6762"/>
                 </a:solidFill>
@@ -5169,7 +5465,7 @@
                 <a:spcPct val="115000"/>
               </a:lnSpc>
               <a:buNone/>
-              <a:defRPr sz="1275" b="0">
+              <a:defRPr sz="1200" b="0">
                 <a:solidFill>
                   <a:srgbClr val="6B6762"/>
                 </a:solidFill>
@@ -5179,7 +5475,7 @@
               </a:defRPr>
             </a:pPr>
             <a:r>
-              <a:rPr sz="1275" b="0">
+              <a:rPr sz="1200" b="0">
                 <a:solidFill>
                   <a:srgbClr val="6B6762"/>
                 </a:solidFill>
@@ -5187,7 +5483,7 @@
                 <a:ea typeface="Lato"/>
                 <a:cs typeface="Lato"/>
               </a:rPr>
-              <a:t>Everybody is in the meeting</a:t>
+              <a:t>A game, or straight to business</a:t>
             </a:r>
           </a:p>
         </p:txBody>
@@ -5197,7 +5493,7 @@
           <p:cNvPr id="7" name="">
             <a:extLst xmlns:a="http://schemas.openxmlformats.org/drawingml/2006/main">
               <a:ext uri="{FF2B5EF4-FFF2-40B4-BE49-F238E27FC236}">
-                <a16:creationId xmlns:a16="http://schemas.microsoft.com/office/drawing/2014/main" id="{1FDCBDF0-8AC8-42A9-A2A4-EEBF4C73A3DE}"/>
+                <a16:creationId xmlns:a16="http://schemas.microsoft.com/office/drawing/2014/main" id="{BD09FB96-1C19-4F49-9D66-9FD9162928F8}"/>
               </a:ext>
             </a:extLst>
           </p:cNvPr>
@@ -5208,7 +5504,7 @@
         </p:nvSpPr>
         <p:spPr>
           <a:xfrm xmlns:a="http://schemas.openxmlformats.org/drawingml/2006/main">
-            <a:off x="6210300" y="2381250"/>
+            <a:off x="6210300" y="2190750"/>
             <a:ext cx="2476500" cy="1428750"/>
           </a:xfrm>
           <a:prstGeom xmlns:a="http://schemas.openxmlformats.org/drawingml/2006/main" prst="roundRect">
@@ -5231,7 +5527,7 @@
           </a:bodyPr>
           <a:lstStyle xmlns:a="http://schemas.openxmlformats.org/drawingml/2006/main">
             <a:defPPr>
-              <a:defRPr sz="1500" b="1">
+              <a:defRPr sz="1425" b="1">
                 <a:solidFill>
                   <a:srgbClr val="B3451F"/>
                 </a:solidFill>
@@ -5244,7 +5540,7 @@
           <a:p xmlns:a="http://schemas.openxmlformats.org/drawingml/2006/main">
             <a:pPr>
               <a:buNone/>
-              <a:defRPr sz="1500" b="1">
+              <a:defRPr sz="1425" b="1">
                 <a:solidFill>
                   <a:srgbClr val="B3451F"/>
                 </a:solidFill>
@@ -5254,7 +5550,7 @@
               </a:defRPr>
             </a:pPr>
             <a:r>
-              <a:rPr sz="1500" b="1">
+              <a:rPr sz="1425" b="1">
                 <a:solidFill>
                   <a:srgbClr val="B3451F"/>
                 </a:solidFill>
@@ -5262,7 +5558,7 @@
                 <a:ea typeface="Lato"/>
                 <a:cs typeface="Lato"/>
               </a:rPr>
-              <a:t>3  THINK</a:t>
+              <a:t>3  AGENDA</a:t>
             </a:r>
           </a:p>
         </p:txBody>
@@ -5272,7 +5568,7 @@
           <p:cNvPr id="8" name="">
             <a:extLst xmlns:a="http://schemas.openxmlformats.org/drawingml/2006/main">
               <a:ext uri="{FF2B5EF4-FFF2-40B4-BE49-F238E27FC236}">
-                <a16:creationId xmlns:a16="http://schemas.microsoft.com/office/drawing/2014/main" id="{5301E280-EF46-4899-BE7B-6C44B9F9A589}"/>
+                <a16:creationId xmlns:a16="http://schemas.microsoft.com/office/drawing/2014/main" id="{12C1C012-CA72-42B7-A27B-01AA0910B855}"/>
               </a:ext>
             </a:extLst>
           </p:cNvPr>
@@ -5283,8 +5579,8 @@
         </p:nvSpPr>
         <p:spPr>
           <a:xfrm xmlns:a="http://schemas.openxmlformats.org/drawingml/2006/main">
-            <a:off x="6400800" y="3009900"/>
-            <a:ext cx="2095500" cy="571500"/>
+            <a:off x="6400800" y="2781300"/>
+            <a:ext cx="2095500" cy="666750"/>
           </a:xfrm>
           <a:prstGeom xmlns:a="http://schemas.openxmlformats.org/drawingml/2006/main" prst="rect">
             <a:avLst/>
@@ -5300,7 +5596,7 @@
           </a:bodyPr>
           <a:lstStyle xmlns:a="http://schemas.openxmlformats.org/drawingml/2006/main">
             <a:defPPr algn="l">
-              <a:defRPr sz="1275" b="0">
+              <a:defRPr sz="1200" b="0">
                 <a:solidFill>
                   <a:srgbClr val="6B6762"/>
                 </a:solidFill>
@@ -5316,7 +5612,7 @@
                 <a:spcPct val="115000"/>
               </a:lnSpc>
               <a:buNone/>
-              <a:defRPr sz="1275" b="0">
+              <a:defRPr sz="1200" b="0">
                 <a:solidFill>
                   <a:srgbClr val="6B6762"/>
                 </a:solidFill>
@@ -5326,7 +5622,7 @@
               </a:defRPr>
             </a:pPr>
             <a:r>
-              <a:rPr sz="1275" b="0">
+              <a:rPr sz="1200" b="0">
                 <a:solidFill>
                   <a:srgbClr val="6B6762"/>
                 </a:solidFill>
@@ -5334,7 +5630,7 @@
                 <a:ea typeface="Lato"/>
                 <a:cs typeface="Lato"/>
               </a:rPr>
-              <a:t>Ideas land in seconds</a:t>
+              <a:t>One item at a time</a:t>
             </a:r>
           </a:p>
         </p:txBody>
@@ -5344,7 +5640,7 @@
           <p:cNvPr id="9" name="">
             <a:extLst xmlns:a="http://schemas.openxmlformats.org/drawingml/2006/main">
               <a:ext uri="{FF2B5EF4-FFF2-40B4-BE49-F238E27FC236}">
-                <a16:creationId xmlns:a16="http://schemas.microsoft.com/office/drawing/2014/main" id="{F72A0EB6-8992-4289-B719-842FC2AF6B48}"/>
+                <a16:creationId xmlns:a16="http://schemas.microsoft.com/office/drawing/2014/main" id="{6B79CA19-A6BD-4BC9-8A62-377B891C75A1}"/>
               </a:ext>
             </a:extLst>
           </p:cNvPr>
@@ -5355,7 +5651,7 @@
         </p:nvSpPr>
         <p:spPr>
           <a:xfrm xmlns:a="http://schemas.openxmlformats.org/drawingml/2006/main">
-            <a:off x="8972550" y="2381250"/>
+            <a:off x="8972550" y="2190750"/>
             <a:ext cx="2476500" cy="1428750"/>
           </a:xfrm>
           <a:prstGeom xmlns:a="http://schemas.openxmlformats.org/drawingml/2006/main" prst="roundRect">
@@ -5378,7 +5674,7 @@
           </a:bodyPr>
           <a:lstStyle xmlns:a="http://schemas.openxmlformats.org/drawingml/2006/main">
             <a:defPPr>
-              <a:defRPr sz="1500" b="1">
+              <a:defRPr sz="1425" b="1">
                 <a:solidFill>
                   <a:srgbClr val="0F766E"/>
                 </a:solidFill>
@@ -5391,7 +5687,7 @@
           <a:p xmlns:a="http://schemas.openxmlformats.org/drawingml/2006/main">
             <a:pPr>
               <a:buNone/>
-              <a:defRPr sz="1500" b="1">
+              <a:defRPr sz="1425" b="1">
                 <a:solidFill>
                   <a:srgbClr val="0F766E"/>
                 </a:solidFill>
@@ -5401,7 +5697,7 @@
               </a:defRPr>
             </a:pPr>
             <a:r>
-              <a:rPr sz="1500" b="1">
+              <a:rPr sz="1425" b="1">
                 <a:solidFill>
                   <a:srgbClr val="0F766E"/>
                 </a:solidFill>
@@ -5419,7 +5715,7 @@
           <p:cNvPr id="10" name="">
             <a:extLst xmlns:a="http://schemas.openxmlformats.org/drawingml/2006/main">
               <a:ext uri="{FF2B5EF4-FFF2-40B4-BE49-F238E27FC236}">
-                <a16:creationId xmlns:a16="http://schemas.microsoft.com/office/drawing/2014/main" id="{4671851D-CD4D-488C-96B8-8C5188C4D630}"/>
+                <a16:creationId xmlns:a16="http://schemas.microsoft.com/office/drawing/2014/main" id="{611DDF8D-5695-4B76-B3D5-A0D0063B60E3}"/>
               </a:ext>
             </a:extLst>
           </p:cNvPr>
@@ -5430,8 +5726,8 @@
         </p:nvSpPr>
         <p:spPr>
           <a:xfrm xmlns:a="http://schemas.openxmlformats.org/drawingml/2006/main">
-            <a:off x="9163050" y="3009900"/>
-            <a:ext cx="2095500" cy="571500"/>
+            <a:off x="9163050" y="2781300"/>
+            <a:ext cx="2095500" cy="666750"/>
           </a:xfrm>
           <a:prstGeom xmlns:a="http://schemas.openxmlformats.org/drawingml/2006/main" prst="rect">
             <a:avLst/>
@@ -5447,7 +5743,7 @@
           </a:bodyPr>
           <a:lstStyle xmlns:a="http://schemas.openxmlformats.org/drawingml/2006/main">
             <a:defPPr algn="l">
-              <a:defRPr sz="1275" b="0">
+              <a:defRPr sz="1200" b="0">
                 <a:solidFill>
                   <a:srgbClr val="6B6762"/>
                 </a:solidFill>
@@ -5463,7 +5759,7 @@
                 <a:spcPct val="115000"/>
               </a:lnSpc>
               <a:buNone/>
-              <a:defRPr sz="1275" b="0">
+              <a:defRPr sz="1200" b="0">
                 <a:solidFill>
                   <a:srgbClr val="6B6762"/>
                 </a:solidFill>
@@ -5473,7 +5769,7 @@
               </a:defRPr>
             </a:pPr>
             <a:r>
-              <a:rPr sz="1275" b="0">
+              <a:rPr sz="1200" b="0">
                 <a:solidFill>
                   <a:srgbClr val="6B6762"/>
                 </a:solidFill>
@@ -5481,7 +5777,7 @@
                 <a:ea typeface="Lato"/>
                 <a:cs typeface="Lato"/>
               </a:rPr>
-              <a:t>The room talks it through</a:t>
+              <a:t>The item is the context</a:t>
             </a:r>
           </a:p>
         </p:txBody>
@@ -5491,7 +5787,7 @@
           <p:cNvPr id="11" name="">
             <a:extLst xmlns:a="http://schemas.openxmlformats.org/drawingml/2006/main">
               <a:ext uri="{FF2B5EF4-FFF2-40B4-BE49-F238E27FC236}">
-                <a16:creationId xmlns:a16="http://schemas.microsoft.com/office/drawing/2014/main" id="{7AB9DB4F-13BF-4F23-AD3B-1A2CDED2592A}"/>
+                <a16:creationId xmlns:a16="http://schemas.microsoft.com/office/drawing/2014/main" id="{5F2734EA-D037-4A65-9667-80A8B89BF6DD}"/>
               </a:ext>
             </a:extLst>
           </p:cNvPr>
@@ -5502,7 +5798,7 @@
         </p:nvSpPr>
         <p:spPr>
           <a:xfrm xmlns:a="http://schemas.openxmlformats.org/drawingml/2006/main">
-            <a:off x="685800" y="4191000"/>
+            <a:off x="685800" y="4000500"/>
             <a:ext cx="2476500" cy="1428750"/>
           </a:xfrm>
           <a:prstGeom xmlns:a="http://schemas.openxmlformats.org/drawingml/2006/main" prst="roundRect">
@@ -5525,7 +5821,7 @@
           </a:bodyPr>
           <a:lstStyle xmlns:a="http://schemas.openxmlformats.org/drawingml/2006/main">
             <a:defPPr>
-              <a:defRPr sz="1500" b="1">
+              <a:defRPr sz="1425" b="1">
                 <a:solidFill>
                   <a:srgbClr val="B3451F"/>
                 </a:solidFill>
@@ -5538,7 +5834,7 @@
           <a:p xmlns:a="http://schemas.openxmlformats.org/drawingml/2006/main">
             <a:pPr>
               <a:buNone/>
-              <a:defRPr sz="1500" b="1">
+              <a:defRPr sz="1425" b="1">
                 <a:solidFill>
                   <a:srgbClr val="B3451F"/>
                 </a:solidFill>
@@ -5548,7 +5844,7 @@
               </a:defRPr>
             </a:pPr>
             <a:r>
-              <a:rPr sz="1500" b="1">
+              <a:rPr sz="1425" b="1">
                 <a:solidFill>
                   <a:srgbClr val="B3451F"/>
                 </a:solidFill>
@@ -5566,7 +5862,7 @@
           <p:cNvPr id="12" name="">
             <a:extLst xmlns:a="http://schemas.openxmlformats.org/drawingml/2006/main">
               <a:ext uri="{FF2B5EF4-FFF2-40B4-BE49-F238E27FC236}">
-                <a16:creationId xmlns:a16="http://schemas.microsoft.com/office/drawing/2014/main" id="{0CEF2A5B-206E-436A-9DA6-F3C9E60D7C8F}"/>
+                <a16:creationId xmlns:a16="http://schemas.microsoft.com/office/drawing/2014/main" id="{1ACA794F-23B4-4309-8573-CDE0EB8C43C6}"/>
               </a:ext>
             </a:extLst>
           </p:cNvPr>
@@ -5577,8 +5873,8 @@
         </p:nvSpPr>
         <p:spPr>
           <a:xfrm xmlns:a="http://schemas.openxmlformats.org/drawingml/2006/main">
-            <a:off x="876300" y="4819650"/>
-            <a:ext cx="2095500" cy="571500"/>
+            <a:off x="876300" y="4591050"/>
+            <a:ext cx="2095500" cy="666750"/>
           </a:xfrm>
           <a:prstGeom xmlns:a="http://schemas.openxmlformats.org/drawingml/2006/main" prst="rect">
             <a:avLst/>
@@ -5594,7 +5890,7 @@
           </a:bodyPr>
           <a:lstStyle xmlns:a="http://schemas.openxmlformats.org/drawingml/2006/main">
             <a:defPPr algn="l">
-              <a:defRPr sz="1275" b="0">
+              <a:defRPr sz="1200" b="0">
                 <a:solidFill>
                   <a:srgbClr val="6B6762"/>
                 </a:solidFill>
@@ -5610,7 +5906,7 @@
                 <a:spcPct val="115000"/>
               </a:lnSpc>
               <a:buNone/>
-              <a:defRPr sz="1275" b="0">
+              <a:defRPr sz="1200" b="0">
                 <a:solidFill>
                   <a:srgbClr val="6B6762"/>
                 </a:solidFill>
@@ -5620,7 +5916,7 @@
               </a:defRPr>
             </a:pPr>
             <a:r>
-              <a:rPr sz="1275" b="0">
+              <a:rPr sz="1200" b="0">
                 <a:solidFill>
                   <a:srgbClr val="6B6762"/>
                 </a:solidFill>
@@ -5628,7 +5924,7 @@
                 <a:ea typeface="Lato"/>
                 <a:cs typeface="Lato"/>
               </a:rPr>
-              <a:t>The agreement is written down</a:t>
+              <a:t>One sentence, recorded</a:t>
             </a:r>
           </a:p>
         </p:txBody>
@@ -5638,7 +5934,7 @@
           <p:cNvPr id="13" name="">
             <a:extLst xmlns:a="http://schemas.openxmlformats.org/drawingml/2006/main">
               <a:ext uri="{FF2B5EF4-FFF2-40B4-BE49-F238E27FC236}">
-                <a16:creationId xmlns:a16="http://schemas.microsoft.com/office/drawing/2014/main" id="{1293A03E-B97C-4056-9316-4ABB9E2018A5}"/>
+                <a16:creationId xmlns:a16="http://schemas.microsoft.com/office/drawing/2014/main" id="{E9E9DC7B-7A45-4E26-924A-31EE8774B254}"/>
               </a:ext>
             </a:extLst>
           </p:cNvPr>
@@ -5649,7 +5945,7 @@
         </p:nvSpPr>
         <p:spPr>
           <a:xfrm xmlns:a="http://schemas.openxmlformats.org/drawingml/2006/main">
-            <a:off x="3448050" y="4191000"/>
+            <a:off x="3448050" y="4000500"/>
             <a:ext cx="2476500" cy="1428750"/>
           </a:xfrm>
           <a:prstGeom xmlns:a="http://schemas.openxmlformats.org/drawingml/2006/main" prst="roundRect">
@@ -5672,7 +5968,7 @@
           </a:bodyPr>
           <a:lstStyle xmlns:a="http://schemas.openxmlformats.org/drawingml/2006/main">
             <a:defPPr>
-              <a:defRPr sz="1500" b="1">
+              <a:defRPr sz="1425" b="1">
                 <a:solidFill>
                   <a:srgbClr val="0F766E"/>
                 </a:solidFill>
@@ -5685,7 +5981,7 @@
           <a:p xmlns:a="http://schemas.openxmlformats.org/drawingml/2006/main">
             <a:pPr>
               <a:buNone/>
-              <a:defRPr sz="1500" b="1">
+              <a:defRPr sz="1425" b="1">
                 <a:solidFill>
                   <a:srgbClr val="0F766E"/>
                 </a:solidFill>
@@ -5695,7 +5991,7 @@
               </a:defRPr>
             </a:pPr>
             <a:r>
-              <a:rPr sz="1500" b="1">
+              <a:rPr sz="1425" b="1">
                 <a:solidFill>
                   <a:srgbClr val="0F766E"/>
                 </a:solidFill>
@@ -5703,7 +5999,7 @@
                 <a:ea typeface="Lato"/>
                 <a:cs typeface="Lato"/>
               </a:rPr>
-              <a:t>6  ASSIGN</a:t>
+              <a:t>6  ACT</a:t>
             </a:r>
           </a:p>
         </p:txBody>
@@ -5713,7 +6009,7 @@
           <p:cNvPr id="14" name="">
             <a:extLst xmlns:a="http://schemas.openxmlformats.org/drawingml/2006/main">
               <a:ext uri="{FF2B5EF4-FFF2-40B4-BE49-F238E27FC236}">
-                <a16:creationId xmlns:a16="http://schemas.microsoft.com/office/drawing/2014/main" id="{61D2E347-8DAF-4DEB-BEF6-4C2AF3396FF1}"/>
+                <a16:creationId xmlns:a16="http://schemas.microsoft.com/office/drawing/2014/main" id="{9C5A35A2-F542-4D0A-B9F3-40DB1C7E096F}"/>
               </a:ext>
             </a:extLst>
           </p:cNvPr>
@@ -5724,8 +6020,8 @@
         </p:nvSpPr>
         <p:spPr>
           <a:xfrm xmlns:a="http://schemas.openxmlformats.org/drawingml/2006/main">
-            <a:off x="3638550" y="4819650"/>
-            <a:ext cx="2095500" cy="571500"/>
+            <a:off x="3638550" y="4591050"/>
+            <a:ext cx="2095500" cy="666750"/>
           </a:xfrm>
           <a:prstGeom xmlns:a="http://schemas.openxmlformats.org/drawingml/2006/main" prst="rect">
             <a:avLst/>
@@ -5741,7 +6037,7 @@
           </a:bodyPr>
           <a:lstStyle xmlns:a="http://schemas.openxmlformats.org/drawingml/2006/main">
             <a:defPPr algn="l">
-              <a:defRPr sz="1275" b="0">
+              <a:defRPr sz="1200" b="0">
                 <a:solidFill>
                   <a:srgbClr val="6B6762"/>
                 </a:solidFill>
@@ -5757,7 +6053,7 @@
                 <a:spcPct val="115000"/>
               </a:lnSpc>
               <a:buNone/>
-              <a:defRPr sz="1275" b="0">
+              <a:defRPr sz="1200" b="0">
                 <a:solidFill>
                   <a:srgbClr val="6B6762"/>
                 </a:solidFill>
@@ -5767,7 +6063,7 @@
               </a:defRPr>
             </a:pPr>
             <a:r>
-              <a:rPr sz="1275" b="0">
+              <a:rPr sz="1200" b="0">
                 <a:solidFill>
                   <a:srgbClr val="6B6762"/>
                 </a:solidFill>
@@ -5775,7 +6071,7 @@
                 <a:ea typeface="Lato"/>
                 <a:cs typeface="Lato"/>
               </a:rPr>
-              <a:t>One owner for each task</a:t>
+              <a:t>One owner for what matters</a:t>
             </a:r>
           </a:p>
         </p:txBody>
@@ -5785,7 +6081,7 @@
           <p:cNvPr id="15" name="">
             <a:extLst xmlns:a="http://schemas.openxmlformats.org/drawingml/2006/main">
               <a:ext uri="{FF2B5EF4-FFF2-40B4-BE49-F238E27FC236}">
-                <a16:creationId xmlns:a16="http://schemas.microsoft.com/office/drawing/2014/main" id="{75997194-FFA9-4211-8390-39CE0669B2FC}"/>
+                <a16:creationId xmlns:a16="http://schemas.microsoft.com/office/drawing/2014/main" id="{1D81E487-C627-4ED6-9681-8290851F3BD2}"/>
               </a:ext>
             </a:extLst>
           </p:cNvPr>
@@ -5796,7 +6092,7 @@
         </p:nvSpPr>
         <p:spPr>
           <a:xfrm xmlns:a="http://schemas.openxmlformats.org/drawingml/2006/main">
-            <a:off x="6210300" y="4191000"/>
+            <a:off x="6210300" y="4000500"/>
             <a:ext cx="2476500" cy="1428750"/>
           </a:xfrm>
           <a:prstGeom xmlns:a="http://schemas.openxmlformats.org/drawingml/2006/main" prst="roundRect">
@@ -5819,7 +6115,7 @@
           </a:bodyPr>
           <a:lstStyle xmlns:a="http://schemas.openxmlformats.org/drawingml/2006/main">
             <a:defPPr>
-              <a:defRPr sz="1500" b="1">
+              <a:defRPr sz="1425" b="1">
                 <a:solidFill>
                   <a:srgbClr val="B3451F"/>
                 </a:solidFill>
@@ -5832,7 +6128,7 @@
           <a:p xmlns:a="http://schemas.openxmlformats.org/drawingml/2006/main">
             <a:pPr>
               <a:buNone/>
-              <a:defRPr sz="1500" b="1">
+              <a:defRPr sz="1425" b="1">
                 <a:solidFill>
                   <a:srgbClr val="B3451F"/>
                 </a:solidFill>
@@ -5842,7 +6138,7 @@
               </a:defRPr>
             </a:pPr>
             <a:r>
-              <a:rPr sz="1500" b="1">
+              <a:rPr sz="1425" b="1">
                 <a:solidFill>
                   <a:srgbClr val="B3451F"/>
                 </a:solidFill>
@@ -5850,7 +6146,7 @@
                 <a:ea typeface="Lato"/>
                 <a:cs typeface="Lato"/>
               </a:rPr>
-              <a:t>7  DO</a:t>
+              <a:t>7  WRAP</a:t>
             </a:r>
           </a:p>
         </p:txBody>
@@ -5860,7 +6156,7 @@
           <p:cNvPr id="16" name="">
             <a:extLst xmlns:a="http://schemas.openxmlformats.org/drawingml/2006/main">
               <a:ext uri="{FF2B5EF4-FFF2-40B4-BE49-F238E27FC236}">
-                <a16:creationId xmlns:a16="http://schemas.microsoft.com/office/drawing/2014/main" id="{7BFFBD92-39E9-4BDE-BEE0-E314C0C2CCBB}"/>
+                <a16:creationId xmlns:a16="http://schemas.microsoft.com/office/drawing/2014/main" id="{706398D2-C95C-4583-9CA9-B68FE16A9D6E}"/>
               </a:ext>
             </a:extLst>
           </p:cNvPr>
@@ -5871,8 +6167,8 @@
         </p:nvSpPr>
         <p:spPr>
           <a:xfrm xmlns:a="http://schemas.openxmlformats.org/drawingml/2006/main">
-            <a:off x="6400800" y="4819650"/>
-            <a:ext cx="2095500" cy="571500"/>
+            <a:off x="6400800" y="4591050"/>
+            <a:ext cx="2095500" cy="666750"/>
           </a:xfrm>
           <a:prstGeom xmlns:a="http://schemas.openxmlformats.org/drawingml/2006/main" prst="rect">
             <a:avLst/>
@@ -5888,7 +6184,7 @@
           </a:bodyPr>
           <a:lstStyle xmlns:a="http://schemas.openxmlformats.org/drawingml/2006/main">
             <a:defPPr algn="l">
-              <a:defRPr sz="1275" b="0">
+              <a:defRPr sz="1200" b="0">
                 <a:solidFill>
                   <a:srgbClr val="6B6762"/>
                 </a:solidFill>
@@ -5904,7 +6200,7 @@
                 <a:spcPct val="115000"/>
               </a:lnSpc>
               <a:buNone/>
-              <a:defRPr sz="1275" b="0">
+              <a:defRPr sz="1200" b="0">
                 <a:solidFill>
                   <a:srgbClr val="6B6762"/>
                 </a:solidFill>
@@ -5914,7 +6210,7 @@
               </a:defRPr>
             </a:pPr>
             <a:r>
-              <a:rPr sz="1275" b="0">
+              <a:rPr sz="1200" b="0">
                 <a:solidFill>
                   <a:srgbClr val="6B6762"/>
                 </a:solidFill>
@@ -5922,7 +6218,7 @@
                 <a:ea typeface="Lato"/>
                 <a:cs typeface="Lato"/>
               </a:rPr>
-              <a:t>Work moves on the board</a:t>
+              <a:t>The meeting closes</a:t>
             </a:r>
           </a:p>
         </p:txBody>
@@ -5932,7 +6228,7 @@
           <p:cNvPr id="17" name="">
             <a:extLst xmlns:a="http://schemas.openxmlformats.org/drawingml/2006/main">
               <a:ext uri="{FF2B5EF4-FFF2-40B4-BE49-F238E27FC236}">
-                <a16:creationId xmlns:a16="http://schemas.microsoft.com/office/drawing/2014/main" id="{93E1BF00-79F5-431A-96C8-7B4B50BF1CBF}"/>
+                <a16:creationId xmlns:a16="http://schemas.microsoft.com/office/drawing/2014/main" id="{514E646F-6F2B-4A8A-A309-4A3A7CEAAE26}"/>
               </a:ext>
             </a:extLst>
           </p:cNvPr>
@@ -5943,7 +6239,7 @@
         </p:nvSpPr>
         <p:spPr>
           <a:xfrm xmlns:a="http://schemas.openxmlformats.org/drawingml/2006/main">
-            <a:off x="8972550" y="4191000"/>
+            <a:off x="8972550" y="4000500"/>
             <a:ext cx="2476500" cy="1428750"/>
           </a:xfrm>
           <a:prstGeom xmlns:a="http://schemas.openxmlformats.org/drawingml/2006/main" prst="roundRect">
@@ -5966,7 +6262,7 @@
           </a:bodyPr>
           <a:lstStyle xmlns:a="http://schemas.openxmlformats.org/drawingml/2006/main">
             <a:defPPr>
-              <a:defRPr sz="1500" b="1">
+              <a:defRPr sz="1425" b="1">
                 <a:solidFill>
                   <a:srgbClr val="0F766E"/>
                 </a:solidFill>
@@ -5979,7 +6275,7 @@
           <a:p xmlns:a="http://schemas.openxmlformats.org/drawingml/2006/main">
             <a:pPr>
               <a:buNone/>
-              <a:defRPr sz="1500" b="1">
+              <a:defRPr sz="1425" b="1">
                 <a:solidFill>
                   <a:srgbClr val="0F766E"/>
                 </a:solidFill>
@@ -5989,7 +6285,7 @@
               </a:defRPr>
             </a:pPr>
             <a:r>
-              <a:rPr sz="1500" b="1">
+              <a:rPr sz="1425" b="1">
                 <a:solidFill>
                   <a:srgbClr val="0F766E"/>
                 </a:solidFill>
@@ -5997,7 +6293,7 @@
                 <a:ea typeface="Lato"/>
                 <a:cs typeface="Lato"/>
               </a:rPr>
-              <a:t>8  RECORD</a:t>
+              <a:t>8  MINUTES</a:t>
             </a:r>
           </a:p>
         </p:txBody>
@@ -6007,7 +6303,7 @@
           <p:cNvPr id="18" name="">
             <a:extLst xmlns:a="http://schemas.openxmlformats.org/drawingml/2006/main">
               <a:ext uri="{FF2B5EF4-FFF2-40B4-BE49-F238E27FC236}">
-                <a16:creationId xmlns:a16="http://schemas.microsoft.com/office/drawing/2014/main" id="{1EFB0158-FFD9-47DF-9821-459A72A289A1}"/>
+                <a16:creationId xmlns:a16="http://schemas.microsoft.com/office/drawing/2014/main" id="{4C4C68CB-F4B7-4BF5-8A28-BD21809DBEB3}"/>
               </a:ext>
             </a:extLst>
           </p:cNvPr>
@@ -6018,8 +6314,8 @@
         </p:nvSpPr>
         <p:spPr>
           <a:xfrm xmlns:a="http://schemas.openxmlformats.org/drawingml/2006/main">
-            <a:off x="9163050" y="4819650"/>
-            <a:ext cx="2095500" cy="571500"/>
+            <a:off x="9163050" y="4591050"/>
+            <a:ext cx="2095500" cy="666750"/>
           </a:xfrm>
           <a:prstGeom xmlns:a="http://schemas.openxmlformats.org/drawingml/2006/main" prst="rect">
             <a:avLst/>
@@ -6035,7 +6331,7 @@
           </a:bodyPr>
           <a:lstStyle xmlns:a="http://schemas.openxmlformats.org/drawingml/2006/main">
             <a:defPPr algn="l">
-              <a:defRPr sz="1275" b="0">
+              <a:defRPr sz="1200" b="0">
                 <a:solidFill>
                   <a:srgbClr val="6B6762"/>
                 </a:solidFill>
@@ -6051,7 +6347,7 @@
                 <a:spcPct val="115000"/>
               </a:lnSpc>
               <a:buNone/>
-              <a:defRPr sz="1275" b="0">
+              <a:defRPr sz="1200" b="0">
                 <a:solidFill>
                   <a:srgbClr val="6B6762"/>
                 </a:solidFill>
@@ -6061,7 +6357,7 @@
               </a:defRPr>
             </a:pPr>
             <a:r>
-              <a:rPr sz="1275" b="0">
+              <a:rPr sz="1200" b="0">
                 <a:solidFill>
                   <a:srgbClr val="6B6762"/>
                 </a:solidFill>
@@ -6069,7 +6365,7 @@
                 <a:ea typeface="Lato"/>
                 <a:cs typeface="Lato"/>
               </a:rPr>
-              <a:t>Everything is on the trail</a:t>
+              <a:t>HTML, text and PDF</a:t>
             </a:r>
           </a:p>
         </p:txBody>
@@ -6077,7 +6373,7 @@
     </p:spTree>
     <p:extLst>
       <p:ext uri="{BB962C8B-B14F-4D97-AF65-F5344CB8AC3E}">
-        <p14:creationId xmlns:p14="http://schemas.microsoft.com/office/powerpoint/2010/main" val="1898820798"/>
+        <p14:creationId xmlns:p14="http://schemas.microsoft.com/office/powerpoint/2010/main" val="1653667896"/>
       </p:ext>
     </p:extLst>
   </p:cSld>
@@ -6108,7 +6404,7 @@
           <p:cNvPr id="5" name="">
             <a:extLst xmlns:a="http://schemas.openxmlformats.org/drawingml/2006/main">
               <a:ext uri="{FF2B5EF4-FFF2-40B4-BE49-F238E27FC236}">
-                <a16:creationId xmlns:a16="http://schemas.microsoft.com/office/drawing/2014/main" id="{31E2497D-C510-4D21-9962-CC7BC977772D}"/>
+                <a16:creationId xmlns:a16="http://schemas.microsoft.com/office/drawing/2014/main" id="{E3855AA5-A65C-4D4F-96A0-699538437B75}"/>
               </a:ext>
             </a:extLst>
           </p:cNvPr>
@@ -6119,8 +6415,8 @@
         </p:nvSpPr>
         <p:spPr>
           <a:xfrm xmlns:a="http://schemas.openxmlformats.org/drawingml/2006/main">
-            <a:off x="685800" y="514350"/>
-            <a:ext cx="8572500" cy="457200"/>
+            <a:off x="685800" y="457200"/>
+            <a:ext cx="9525000" cy="438150"/>
           </a:xfrm>
           <a:prstGeom xmlns:a="http://schemas.openxmlformats.org/drawingml/2006/main" prst="rect">
             <a:avLst/>
@@ -6136,7 +6432,7 @@
           </a:bodyPr>
           <a:lstStyle xmlns:a="http://schemas.openxmlformats.org/drawingml/2006/main">
             <a:defPPr algn="l">
-              <a:defRPr sz="2700" b="1">
+              <a:defRPr sz="2550" b="1">
                 <a:solidFill>
                   <a:srgbClr val="12100F"/>
                 </a:solidFill>
@@ -6152,7 +6448,7 @@
                 <a:spcPct val="115000"/>
               </a:lnSpc>
               <a:buNone/>
-              <a:defRPr sz="2700" b="1">
+              <a:defRPr sz="2550" b="1">
                 <a:solidFill>
                   <a:srgbClr val="12100F"/>
                 </a:solidFill>
@@ -6162,7 +6458,7 @@
               </a:defRPr>
             </a:pPr>
             <a:r>
-              <a:rPr sz="2700" b="1">
+              <a:rPr sz="2550" b="1">
                 <a:solidFill>
                   <a:srgbClr val="12100F"/>
                 </a:solidFill>
@@ -6180,7 +6476,7 @@
           <p:cNvPr id="2" name="">
             <a:extLst xmlns:a="http://schemas.openxmlformats.org/drawingml/2006/main">
               <a:ext uri="{FF2B5EF4-FFF2-40B4-BE49-F238E27FC236}">
-                <a16:creationId xmlns:a16="http://schemas.microsoft.com/office/drawing/2014/main" id="{05C0296F-B775-4BAD-8CE0-83461AE06F1E}"/>
+                <a16:creationId xmlns:a16="http://schemas.microsoft.com/office/drawing/2014/main" id="{45051794-853C-4A9C-8D0D-D8F7CFB0D77B}"/>
               </a:ext>
             </a:extLst>
           </p:cNvPr>
@@ -6191,8 +6487,8 @@
         </p:nvSpPr>
         <p:spPr>
           <a:xfrm xmlns:a="http://schemas.openxmlformats.org/drawingml/2006/main">
-            <a:off x="685800" y="1009650"/>
-            <a:ext cx="9906000" cy="571500"/>
+            <a:off x="685800" y="933450"/>
+            <a:ext cx="10096500" cy="533400"/>
           </a:xfrm>
           <a:prstGeom xmlns:a="http://schemas.openxmlformats.org/drawingml/2006/main" prst="rect">
             <a:avLst/>
@@ -6208,7 +6504,7 @@
           </a:bodyPr>
           <a:lstStyle xmlns:a="http://schemas.openxmlformats.org/drawingml/2006/main">
             <a:defPPr algn="l">
-              <a:defRPr sz="1425" b="0">
+              <a:defRPr sz="1350" b="0">
                 <a:solidFill>
                   <a:srgbClr val="6B6762"/>
                 </a:solidFill>
@@ -6224,7 +6520,7 @@
                 <a:spcPct val="115000"/>
               </a:lnSpc>
               <a:buNone/>
-              <a:defRPr sz="1425" b="0">
+              <a:defRPr sz="1350" b="0">
                 <a:solidFill>
                   <a:srgbClr val="6B6762"/>
                 </a:solidFill>
@@ -6234,7 +6530,7 @@
               </a:defRPr>
             </a:pPr>
             <a:r>
-              <a:rPr sz="1425" b="0">
+              <a:rPr sz="1350" b="0">
                 <a:solidFill>
                   <a:srgbClr val="6B6762"/>
                 </a:solidFill>
@@ -6242,7 +6538,7 @@
                 <a:ea typeface="Lato"/>
                 <a:cs typeface="Lato"/>
               </a:rPr>
-              <a:t>Scan the code on the screen with a work email, or open the link a colleague shared. You land in the meeting.</a:t>
+              <a:t>Scan the code on the screen with a work email, or open the link a colleague shared. Latecomers land on the item the room is on.</a:t>
             </a:r>
           </a:p>
         </p:txBody>
@@ -6252,7 +6548,7 @@
           <p:cNvPr id="3" name="">
             <a:extLst xmlns:a="http://schemas.openxmlformats.org/drawingml/2006/main">
               <a:ext uri="{FF2B5EF4-FFF2-40B4-BE49-F238E27FC236}">
-                <a16:creationId xmlns:a16="http://schemas.microsoft.com/office/drawing/2014/main" id="{976753A7-70B7-43EC-8931-08E68BF2329E}"/>
+                <a16:creationId xmlns:a16="http://schemas.microsoft.com/office/drawing/2014/main" id="{FA029C11-C7AB-4435-86EA-23A034289C90}"/>
               </a:ext>
             </a:extLst>
           </p:cNvPr>
@@ -6262,7 +6558,7 @@
           <p:nvPr/>
         </p:nvPicPr>
         <p:blipFill>
-          <a:blip xmlns:r="http://schemas.openxmlformats.org/officeDocument/2006/relationships" xmlns:a="http://schemas.openxmlformats.org/drawingml/2006/main" r:embed="R5479401c19624495"/>
+          <a:blip xmlns:r="http://schemas.openxmlformats.org/officeDocument/2006/relationships" xmlns:a="http://schemas.openxmlformats.org/drawingml/2006/main" r:embed="R6c0fd00435bf4796"/>
           <a:stretch xmlns:a="http://schemas.openxmlformats.org/drawingml/2006/main"/>
         </p:blipFill>
         <p:spPr>
@@ -6282,7 +6578,7 @@
           <p:cNvPr id="4" name="">
             <a:extLst xmlns:a="http://schemas.openxmlformats.org/drawingml/2006/main">
               <a:ext uri="{FF2B5EF4-FFF2-40B4-BE49-F238E27FC236}">
-                <a16:creationId xmlns:a16="http://schemas.microsoft.com/office/drawing/2014/main" id="{E701FCCF-5EF3-4C75-A66A-81FD7439E16B}"/>
+                <a16:creationId xmlns:a16="http://schemas.microsoft.com/office/drawing/2014/main" id="{373586F8-0C28-419E-A744-B7AFBD9F61BB}"/>
               </a:ext>
             </a:extLst>
           </p:cNvPr>
@@ -6292,7 +6588,7 @@
           <p:nvPr/>
         </p:nvPicPr>
         <p:blipFill>
-          <a:blip xmlns:r="http://schemas.openxmlformats.org/officeDocument/2006/relationships" xmlns:a="http://schemas.openxmlformats.org/drawingml/2006/main" r:embed="R89d4f85096e24400"/>
+          <a:blip xmlns:r="http://schemas.openxmlformats.org/officeDocument/2006/relationships" xmlns:a="http://schemas.openxmlformats.org/drawingml/2006/main" r:embed="Rfa98f22cfb344cbd"/>
           <a:stretch xmlns:a="http://schemas.openxmlformats.org/drawingml/2006/main"/>
         </p:blipFill>
         <p:spPr>
@@ -6310,7 +6606,7 @@
     </p:spTree>
     <p:extLst>
       <p:ext uri="{BB962C8B-B14F-4D97-AF65-F5344CB8AC3E}">
-        <p14:creationId xmlns:p14="http://schemas.microsoft.com/office/powerpoint/2010/main" val="1605010702"/>
+        <p14:creationId xmlns:p14="http://schemas.microsoft.com/office/powerpoint/2010/main" val="932051905"/>
       </p:ext>
     </p:extLst>
   </p:cSld>
@@ -6341,7 +6637,7 @@
           <p:cNvPr id="4" name="">
             <a:extLst xmlns:a="http://schemas.openxmlformats.org/drawingml/2006/main">
               <a:ext uri="{FF2B5EF4-FFF2-40B4-BE49-F238E27FC236}">
-                <a16:creationId xmlns:a16="http://schemas.microsoft.com/office/drawing/2014/main" id="{37F1942C-C32A-4006-A885-A73BE10DB0E4}"/>
+                <a16:creationId xmlns:a16="http://schemas.microsoft.com/office/drawing/2014/main" id="{7860C51C-7EE6-469A-91ED-4FB658779F52}"/>
               </a:ext>
             </a:extLst>
           </p:cNvPr>
@@ -6352,8 +6648,8 @@
         </p:nvSpPr>
         <p:spPr>
           <a:xfrm xmlns:a="http://schemas.openxmlformats.org/drawingml/2006/main">
-            <a:off x="685800" y="514350"/>
-            <a:ext cx="8572500" cy="457200"/>
+            <a:off x="685800" y="457200"/>
+            <a:ext cx="9525000" cy="438150"/>
           </a:xfrm>
           <a:prstGeom xmlns:a="http://schemas.openxmlformats.org/drawingml/2006/main" prst="rect">
             <a:avLst/>
@@ -6369,7 +6665,7 @@
           </a:bodyPr>
           <a:lstStyle xmlns:a="http://schemas.openxmlformats.org/drawingml/2006/main">
             <a:defPPr algn="l">
-              <a:defRPr sz="2700" b="1">
+              <a:defRPr sz="2550" b="1">
                 <a:solidFill>
                   <a:srgbClr val="12100F"/>
                 </a:solidFill>
@@ -6385,7 +6681,7 @@
                 <a:spcPct val="115000"/>
               </a:lnSpc>
               <a:buNone/>
-              <a:defRPr sz="2700" b="1">
+              <a:defRPr sz="2550" b="1">
                 <a:solidFill>
                   <a:srgbClr val="12100F"/>
                 </a:solidFill>
@@ -6395,7 +6691,7 @@
               </a:defRPr>
             </a:pPr>
             <a:r>
-              <a:rPr sz="2700" b="1">
+              <a:rPr sz="2550" b="1">
                 <a:solidFill>
                   <a:srgbClr val="12100F"/>
                 </a:solidFill>
@@ -6403,7 +6699,7 @@
                 <a:ea typeface="Lato"/>
                 <a:cs typeface="Lato"/>
               </a:rPr>
-              <a:t>Today</a:t>
+              <a:t>Two ways to open a meeting</a:t>
             </a:r>
           </a:p>
         </p:txBody>
@@ -6413,7 +6709,7 @@
           <p:cNvPr id="2" name="">
             <a:extLst xmlns:a="http://schemas.openxmlformats.org/drawingml/2006/main">
               <a:ext uri="{FF2B5EF4-FFF2-40B4-BE49-F238E27FC236}">
-                <a16:creationId xmlns:a16="http://schemas.microsoft.com/office/drawing/2014/main" id="{7D119861-56C2-451C-97B9-2F04624201FA}"/>
+                <a16:creationId xmlns:a16="http://schemas.microsoft.com/office/drawing/2014/main" id="{7E38DF24-F3D0-46C9-AA07-77FBD67A23BE}"/>
               </a:ext>
             </a:extLst>
           </p:cNvPr>
@@ -6424,8 +6720,8 @@
         </p:nvSpPr>
         <p:spPr>
           <a:xfrm xmlns:a="http://schemas.openxmlformats.org/drawingml/2006/main">
-            <a:off x="685800" y="1009650"/>
-            <a:ext cx="9906000" cy="571500"/>
+            <a:off x="685800" y="933450"/>
+            <a:ext cx="10096500" cy="533400"/>
           </a:xfrm>
           <a:prstGeom xmlns:a="http://schemas.openxmlformats.org/drawingml/2006/main" prst="rect">
             <a:avLst/>
@@ -6441,7 +6737,7 @@
           </a:bodyPr>
           <a:lstStyle xmlns:a="http://schemas.openxmlformats.org/drawingml/2006/main">
             <a:defPPr algn="l">
-              <a:defRPr sz="1425" b="0">
+              <a:defRPr sz="1350" b="0">
                 <a:solidFill>
                   <a:srgbClr val="6B6762"/>
                 </a:solidFill>
@@ -6457,7 +6753,7 @@
                 <a:spcPct val="115000"/>
               </a:lnSpc>
               <a:buNone/>
-              <a:defRPr sz="1425" b="0">
+              <a:defRPr sz="1350" b="0">
                 <a:solidFill>
                   <a:srgbClr val="6B6762"/>
                 </a:solidFill>
@@ -6467,7 +6763,7 @@
               </a:defRPr>
             </a:pPr>
             <a:r>
-              <a:rPr sz="1425" b="0">
+              <a:rPr sz="1350" b="0">
                 <a:solidFill>
                   <a:srgbClr val="6B6762"/>
                 </a:solidFill>
@@ -6475,7 +6771,7 @@
                 <a:ea typeface="Lato"/>
                 <a:cs typeface="Lato"/>
               </a:rPr>
-              <a:t>Your next meeting, your own work and the last meeting's output, on one screen.</a:t>
+              <a:t>Play is the warm-up, not the meeting. A serious meeting goes straight to the agenda.</a:t>
             </a:r>
           </a:p>
         </p:txBody>
@@ -6485,7 +6781,7 @@
           <p:cNvPr id="3" name="">
             <a:extLst xmlns:a="http://schemas.openxmlformats.org/drawingml/2006/main">
               <a:ext uri="{FF2B5EF4-FFF2-40B4-BE49-F238E27FC236}">
-                <a16:creationId xmlns:a16="http://schemas.microsoft.com/office/drawing/2014/main" id="{49E18BCE-B1B3-43DF-A9DE-370343F872FF}"/>
+                <a16:creationId xmlns:a16="http://schemas.microsoft.com/office/drawing/2014/main" id="{6298E2D7-C096-4D35-8E84-C75161F4F9B9}"/>
               </a:ext>
             </a:extLst>
           </p:cNvPr>
@@ -6495,7 +6791,7 @@
           <p:nvPr/>
         </p:nvPicPr>
         <p:blipFill>
-          <a:blip xmlns:r="http://schemas.openxmlformats.org/officeDocument/2006/relationships" xmlns:a="http://schemas.openxmlformats.org/drawingml/2006/main" r:embed="R6f4c23bbbc1f4a31"/>
+          <a:blip xmlns:r="http://schemas.openxmlformats.org/officeDocument/2006/relationships" xmlns:a="http://schemas.openxmlformats.org/drawingml/2006/main" r:embed="R71e8d478bff1401f"/>
           <a:stretch xmlns:a="http://schemas.openxmlformats.org/drawingml/2006/main"/>
         </p:blipFill>
         <p:spPr>
@@ -6513,7 +6809,7 @@
     </p:spTree>
     <p:extLst>
       <p:ext uri="{BB962C8B-B14F-4D97-AF65-F5344CB8AC3E}">
-        <p14:creationId xmlns:p14="http://schemas.microsoft.com/office/powerpoint/2010/main" val="858969659"/>
+        <p14:creationId xmlns:p14="http://schemas.microsoft.com/office/powerpoint/2010/main" val="1298757680"/>
       </p:ext>
     </p:extLst>
   </p:cSld>
@@ -6541,10 +6837,10 @@
       </p:grpSpPr>
       <p:sp>
         <p:nvSpPr>
-          <p:cNvPr id="4" name="">
+          <p:cNvPr id="5" name="">
             <a:extLst xmlns:a="http://schemas.openxmlformats.org/drawingml/2006/main">
               <a:ext uri="{FF2B5EF4-FFF2-40B4-BE49-F238E27FC236}">
-                <a16:creationId xmlns:a16="http://schemas.microsoft.com/office/drawing/2014/main" id="{7A6F820B-BFEB-419D-B41E-9BF550E70686}"/>
+                <a16:creationId xmlns:a16="http://schemas.microsoft.com/office/drawing/2014/main" id="{4BFF7060-217D-420D-9B92-08C8DA1E7CB5}"/>
               </a:ext>
             </a:extLst>
           </p:cNvPr>
@@ -6555,8 +6851,8 @@
         </p:nvSpPr>
         <p:spPr>
           <a:xfrm xmlns:a="http://schemas.openxmlformats.org/drawingml/2006/main">
-            <a:off x="685800" y="514350"/>
-            <a:ext cx="8572500" cy="457200"/>
+            <a:off x="685800" y="457200"/>
+            <a:ext cx="9525000" cy="438150"/>
           </a:xfrm>
           <a:prstGeom xmlns:a="http://schemas.openxmlformats.org/drawingml/2006/main" prst="rect">
             <a:avLst/>
@@ -6572,7 +6868,7 @@
           </a:bodyPr>
           <a:lstStyle xmlns:a="http://schemas.openxmlformats.org/drawingml/2006/main">
             <a:defPPr algn="l">
-              <a:defRPr sz="2700" b="1">
+              <a:defRPr sz="2550" b="1">
                 <a:solidFill>
                   <a:srgbClr val="12100F"/>
                 </a:solidFill>
@@ -6588,7 +6884,7 @@
                 <a:spcPct val="115000"/>
               </a:lnSpc>
               <a:buNone/>
-              <a:defRPr sz="2700" b="1">
+              <a:defRPr sz="2550" b="1">
                 <a:solidFill>
                   <a:srgbClr val="12100F"/>
                 </a:solidFill>
@@ -6598,7 +6894,7 @@
               </a:defRPr>
             </a:pPr>
             <a:r>
-              <a:rPr sz="2700" b="1">
+              <a:rPr sz="2550" b="1">
                 <a:solidFill>
                   <a:srgbClr val="12100F"/>
                 </a:solidFill>
@@ -6606,7 +6902,7 @@
                 <a:ea typeface="Lato"/>
                 <a:cs typeface="Lato"/>
               </a:rPr>
-              <a:t>Running a meeting</a:t>
+              <a:t>The game, when the room wants one</a:t>
             </a:r>
           </a:p>
         </p:txBody>
@@ -6616,7 +6912,7 @@
           <p:cNvPr id="2" name="">
             <a:extLst xmlns:a="http://schemas.openxmlformats.org/drawingml/2006/main">
               <a:ext uri="{FF2B5EF4-FFF2-40B4-BE49-F238E27FC236}">
-                <a16:creationId xmlns:a16="http://schemas.microsoft.com/office/drawing/2014/main" id="{7004E0F2-4369-4A25-B678-53B509F239A5}"/>
+                <a16:creationId xmlns:a16="http://schemas.microsoft.com/office/drawing/2014/main" id="{707A078E-3877-4488-BF18-90381566EF00}"/>
               </a:ext>
             </a:extLst>
           </p:cNvPr>
@@ -6627,8 +6923,8 @@
         </p:nvSpPr>
         <p:spPr>
           <a:xfrm xmlns:a="http://schemas.openxmlformats.org/drawingml/2006/main">
-            <a:off x="685800" y="1009650"/>
-            <a:ext cx="9906000" cy="571500"/>
+            <a:off x="685800" y="933450"/>
+            <a:ext cx="10096500" cy="533400"/>
           </a:xfrm>
           <a:prstGeom xmlns:a="http://schemas.openxmlformats.org/drawingml/2006/main" prst="rect">
             <a:avLst/>
@@ -6644,7 +6940,7 @@
           </a:bodyPr>
           <a:lstStyle xmlns:a="http://schemas.openxmlformats.org/drawingml/2006/main">
             <a:defPPr algn="l">
-              <a:defRPr sz="1425" b="0">
+              <a:defRPr sz="1350" b="0">
                 <a:solidFill>
                   <a:srgbClr val="6B6762"/>
                 </a:solidFill>
@@ -6660,7 +6956,7 @@
                 <a:spcPct val="115000"/>
               </a:lnSpc>
               <a:buNone/>
-              <a:defRPr sz="1425" b="0">
+              <a:defRPr sz="1350" b="0">
                 <a:solidFill>
                   <a:srgbClr val="6B6762"/>
                 </a:solidFill>
@@ -6670,7 +6966,7 @@
               </a:defRPr>
             </a:pPr>
             <a:r>
-              <a:rPr sz="1425" b="0">
+              <a:rPr sz="1350" b="0">
                 <a:solidFill>
                   <a:srgbClr val="6B6762"/>
                 </a:solidFill>
@@ -6678,7 +6974,7 @@
                 <a:ea typeface="Lato"/>
                 <a:cs typeface="Lato"/>
               </a:rPr>
-              <a:t>One action per screen. The facilitator taps, and every phone follows to the same stage.</a:t>
+              <a:t>One question on the shared screen, and every phone answering the same one on the same clock.</a:t>
             </a:r>
           </a:p>
         </p:txBody>
@@ -6688,7 +6984,7 @@
           <p:cNvPr id="3" name="">
             <a:extLst xmlns:a="http://schemas.openxmlformats.org/drawingml/2006/main">
               <a:ext uri="{FF2B5EF4-FFF2-40B4-BE49-F238E27FC236}">
-                <a16:creationId xmlns:a16="http://schemas.microsoft.com/office/drawing/2014/main" id="{253C7AFB-D974-4B51-B440-E6608C0F6554}"/>
+                <a16:creationId xmlns:a16="http://schemas.microsoft.com/office/drawing/2014/main" id="{778FBD44-2297-4DF6-918B-1B628924117E}"/>
               </a:ext>
             </a:extLst>
           </p:cNvPr>
@@ -6698,17 +6994,47 @@
           <p:nvPr/>
         </p:nvPicPr>
         <p:blipFill>
-          <a:blip xmlns:r="http://schemas.openxmlformats.org/officeDocument/2006/relationships" xmlns:a="http://schemas.openxmlformats.org/drawingml/2006/main" r:embed="R89ff113681c64a80"/>
+          <a:blip xmlns:r="http://schemas.openxmlformats.org/officeDocument/2006/relationships" xmlns:a="http://schemas.openxmlformats.org/drawingml/2006/main" r:embed="Rd1f748ee13cd4bac"/>
           <a:stretch xmlns:a="http://schemas.openxmlformats.org/drawingml/2006/main"/>
         </p:blipFill>
         <p:spPr>
           <a:xfrm xmlns:a="http://schemas.openxmlformats.org/drawingml/2006/main">
-            <a:off x="1811867" y="1866900"/>
-            <a:ext cx="8568267" cy="4819650"/>
+            <a:off x="3429000" y="2000250"/>
+            <a:ext cx="8077200" cy="4543425"/>
           </a:xfrm>
           <a:prstGeom xmlns:a="http://schemas.openxmlformats.org/drawingml/2006/main" prst="roundRect">
             <a:avLst>
-              <a:gd name="adj" fmla="val 2372"/>
+              <a:gd name="adj" fmla="val 2516"/>
+            </a:avLst>
+          </a:prstGeom>
+        </p:spPr>
+      </p:pic>
+      <p:pic>
+        <p:nvPicPr>
+          <p:cNvPr id="4" name="">
+            <a:extLst xmlns:a="http://schemas.openxmlformats.org/drawingml/2006/main">
+              <a:ext uri="{FF2B5EF4-FFF2-40B4-BE49-F238E27FC236}">
+                <a16:creationId xmlns:a16="http://schemas.microsoft.com/office/drawing/2014/main" id="{9EBF395A-FE95-4220-B21E-4EDC33C8B948}"/>
+              </a:ext>
+            </a:extLst>
+          </p:cNvPr>
+          <p:cNvPicPr>
+            <a:picLocks xmlns:a="http://schemas.openxmlformats.org/drawingml/2006/main" noChangeAspect="1"/>
+          </p:cNvPicPr>
+          <p:nvPr/>
+        </p:nvPicPr>
+        <p:blipFill>
+          <a:blip xmlns:r="http://schemas.openxmlformats.org/officeDocument/2006/relationships" xmlns:a="http://schemas.openxmlformats.org/drawingml/2006/main" r:embed="Rf40aee961bcf4adb"/>
+          <a:stretch xmlns:a="http://schemas.openxmlformats.org/drawingml/2006/main"/>
+        </p:blipFill>
+        <p:spPr>
+          <a:xfrm xmlns:a="http://schemas.openxmlformats.org/drawingml/2006/main">
+            <a:off x="915348" y="2000250"/>
+            <a:ext cx="2112654" cy="4572000"/>
+          </a:xfrm>
+          <a:prstGeom xmlns:a="http://schemas.openxmlformats.org/drawingml/2006/main" prst="roundRect">
+            <a:avLst>
+              <a:gd name="adj" fmla="val 5405"/>
             </a:avLst>
           </a:prstGeom>
         </p:spPr>
@@ -6716,7 +7042,7 @@
     </p:spTree>
     <p:extLst>
       <p:ext uri="{BB962C8B-B14F-4D97-AF65-F5344CB8AC3E}">
-        <p14:creationId xmlns:p14="http://schemas.microsoft.com/office/powerpoint/2010/main" val="926656182"/>
+        <p14:creationId xmlns:p14="http://schemas.microsoft.com/office/powerpoint/2010/main" val="1209816933"/>
       </p:ext>
     </p:extLst>
   </p:cSld>
@@ -6747,7 +7073,7 @@
           <p:cNvPr id="5" name="">
             <a:extLst xmlns:a="http://schemas.openxmlformats.org/drawingml/2006/main">
               <a:ext uri="{FF2B5EF4-FFF2-40B4-BE49-F238E27FC236}">
-                <a16:creationId xmlns:a16="http://schemas.microsoft.com/office/drawing/2014/main" id="{36C4BADA-827D-4E63-9F7A-7124E8272845}"/>
+                <a16:creationId xmlns:a16="http://schemas.microsoft.com/office/drawing/2014/main" id="{F2084574-F4A4-494A-AB6C-D1643C6A9CF1}"/>
               </a:ext>
             </a:extLst>
           </p:cNvPr>
@@ -6758,8 +7084,8 @@
         </p:nvSpPr>
         <p:spPr>
           <a:xfrm xmlns:a="http://schemas.openxmlformats.org/drawingml/2006/main">
-            <a:off x="685800" y="514350"/>
-            <a:ext cx="8572500" cy="457200"/>
+            <a:off x="685800" y="457200"/>
+            <a:ext cx="9525000" cy="438150"/>
           </a:xfrm>
           <a:prstGeom xmlns:a="http://schemas.openxmlformats.org/drawingml/2006/main" prst="rect">
             <a:avLst/>
@@ -6775,7 +7101,7 @@
           </a:bodyPr>
           <a:lstStyle xmlns:a="http://schemas.openxmlformats.org/drawingml/2006/main">
             <a:defPPr algn="l">
-              <a:defRPr sz="2700" b="1">
+              <a:defRPr sz="2550" b="1">
                 <a:solidFill>
                   <a:srgbClr val="12100F"/>
                 </a:solidFill>
@@ -6791,7 +7117,7 @@
                 <a:spcPct val="115000"/>
               </a:lnSpc>
               <a:buNone/>
-              <a:defRPr sz="2700" b="1">
+              <a:defRPr sz="2550" b="1">
                 <a:solidFill>
                   <a:srgbClr val="12100F"/>
                 </a:solidFill>
@@ -6801,7 +7127,7 @@
               </a:defRPr>
             </a:pPr>
             <a:r>
-              <a:rPr sz="2700" b="1">
+              <a:rPr sz="2550" b="1">
                 <a:solidFill>
                   <a:srgbClr val="12100F"/>
                 </a:solidFill>
@@ -6809,7 +7135,7 @@
                 <a:ea typeface="Lato"/>
                 <a:cs typeface="Lato"/>
               </a:rPr>
-              <a:t>The game</a:t>
+              <a:t>The reveal and the results</a:t>
             </a:r>
           </a:p>
         </p:txBody>
@@ -6819,7 +7145,7 @@
           <p:cNvPr id="2" name="">
             <a:extLst xmlns:a="http://schemas.openxmlformats.org/drawingml/2006/main">
               <a:ext uri="{FF2B5EF4-FFF2-40B4-BE49-F238E27FC236}">
-                <a16:creationId xmlns:a16="http://schemas.microsoft.com/office/drawing/2014/main" id="{73A9F365-6459-4472-8E52-4F4106743AA9}"/>
+                <a16:creationId xmlns:a16="http://schemas.microsoft.com/office/drawing/2014/main" id="{CE454102-CEAE-4421-85B3-0E98847CC59C}"/>
               </a:ext>
             </a:extLst>
           </p:cNvPr>
@@ -6830,8 +7156,8 @@
         </p:nvSpPr>
         <p:spPr>
           <a:xfrm xmlns:a="http://schemas.openxmlformats.org/drawingml/2006/main">
-            <a:off x="685800" y="1009650"/>
-            <a:ext cx="9906000" cy="571500"/>
+            <a:off x="685800" y="933450"/>
+            <a:ext cx="10096500" cy="533400"/>
           </a:xfrm>
           <a:prstGeom xmlns:a="http://schemas.openxmlformats.org/drawingml/2006/main" prst="rect">
             <a:avLst/>
@@ -6847,7 +7173,7 @@
           </a:bodyPr>
           <a:lstStyle xmlns:a="http://schemas.openxmlformats.org/drawingml/2006/main">
             <a:defPPr algn="l">
-              <a:defRPr sz="1425" b="0">
+              <a:defRPr sz="1350" b="0">
                 <a:solidFill>
                   <a:srgbClr val="6B6762"/>
                 </a:solidFill>
@@ -6863,7 +7189,7 @@
                 <a:spcPct val="115000"/>
               </a:lnSpc>
               <a:buNone/>
-              <a:defRPr sz="1425" b="0">
+              <a:defRPr sz="1350" b="0">
                 <a:solidFill>
                   <a:srgbClr val="6B6762"/>
                 </a:solidFill>
@@ -6873,7 +7199,7 @@
               </a:defRPr>
             </a:pPr>
             <a:r>
-              <a:rPr sz="1425" b="0">
+              <a:rPr sz="1350" b="0">
                 <a:solidFill>
                   <a:srgbClr val="6B6762"/>
                 </a:solidFill>
@@ -6881,7 +7207,7 @@
                 <a:ea typeface="Lato"/>
                 <a:cs typeface="Lato"/>
               </a:rPr>
-              <a:t>The same question on the shared screen and on every phone. One clock for the room, one answer each.</a:t>
+              <a:t>The host reveals once and the right answers score together. Ten points, plus five for a quick answer.</a:t>
             </a:r>
           </a:p>
         </p:txBody>
@@ -6891,7 +7217,7 @@
           <p:cNvPr id="3" name="">
             <a:extLst xmlns:a="http://schemas.openxmlformats.org/drawingml/2006/main">
               <a:ext uri="{FF2B5EF4-FFF2-40B4-BE49-F238E27FC236}">
-                <a16:creationId xmlns:a16="http://schemas.microsoft.com/office/drawing/2014/main" id="{B6F6F379-F08B-4DD3-87AC-889378AE6948}"/>
+                <a16:creationId xmlns:a16="http://schemas.microsoft.com/office/drawing/2014/main" id="{1D5B2F55-1B98-426C-AF9F-31926F3054A2}"/>
               </a:ext>
             </a:extLst>
           </p:cNvPr>
@@ -6901,17 +7227,17 @@
           <p:nvPr/>
         </p:nvPicPr>
         <p:blipFill>
-          <a:blip xmlns:r="http://schemas.openxmlformats.org/officeDocument/2006/relationships" xmlns:a="http://schemas.openxmlformats.org/drawingml/2006/main" r:embed="R9a18f4816baa4faf"/>
+          <a:blip xmlns:r="http://schemas.openxmlformats.org/officeDocument/2006/relationships" xmlns:a="http://schemas.openxmlformats.org/drawingml/2006/main" r:embed="R98b2480ed1284586"/>
           <a:stretch xmlns:a="http://schemas.openxmlformats.org/drawingml/2006/main"/>
         </p:blipFill>
         <p:spPr>
           <a:xfrm xmlns:a="http://schemas.openxmlformats.org/drawingml/2006/main">
-            <a:off x="3429000" y="2047875"/>
-            <a:ext cx="8077200" cy="4543425"/>
+            <a:off x="685800" y="2383631"/>
+            <a:ext cx="5257800" cy="2957513"/>
           </a:xfrm>
           <a:prstGeom xmlns:a="http://schemas.openxmlformats.org/drawingml/2006/main" prst="roundRect">
             <a:avLst>
-              <a:gd name="adj" fmla="val 2516"/>
+              <a:gd name="adj" fmla="val 3859"/>
             </a:avLst>
           </a:prstGeom>
         </p:spPr>
@@ -6921,7 +7247,7 @@
           <p:cNvPr id="4" name="">
             <a:extLst xmlns:a="http://schemas.openxmlformats.org/drawingml/2006/main">
               <a:ext uri="{FF2B5EF4-FFF2-40B4-BE49-F238E27FC236}">
-                <a16:creationId xmlns:a16="http://schemas.microsoft.com/office/drawing/2014/main" id="{DFDFD9D6-B46B-40E5-AFFF-7EFF98395000}"/>
+                <a16:creationId xmlns:a16="http://schemas.microsoft.com/office/drawing/2014/main" id="{DE7E1EB4-A43C-42D9-8FF6-AE6224F9CCE6}"/>
               </a:ext>
             </a:extLst>
           </p:cNvPr>
@@ -6931,17 +7257,17 @@
           <p:nvPr/>
         </p:nvPicPr>
         <p:blipFill>
-          <a:blip xmlns:r="http://schemas.openxmlformats.org/officeDocument/2006/relationships" xmlns:a="http://schemas.openxmlformats.org/drawingml/2006/main" r:embed="R4ed77e1acfb14fc3"/>
+          <a:blip xmlns:r="http://schemas.openxmlformats.org/officeDocument/2006/relationships" xmlns:a="http://schemas.openxmlformats.org/drawingml/2006/main" r:embed="R757330606c0f41a0"/>
           <a:stretch xmlns:a="http://schemas.openxmlformats.org/drawingml/2006/main"/>
         </p:blipFill>
         <p:spPr>
           <a:xfrm xmlns:a="http://schemas.openxmlformats.org/drawingml/2006/main">
-            <a:off x="915348" y="2000250"/>
-            <a:ext cx="2112654" cy="4572000"/>
+            <a:off x="6248400" y="2383631"/>
+            <a:ext cx="5257800" cy="2957513"/>
           </a:xfrm>
           <a:prstGeom xmlns:a="http://schemas.openxmlformats.org/drawingml/2006/main" prst="roundRect">
             <a:avLst>
-              <a:gd name="adj" fmla="val 5405"/>
+              <a:gd name="adj" fmla="val 3859"/>
             </a:avLst>
           </a:prstGeom>
         </p:spPr>
@@ -6949,7 +7275,7 @@
     </p:spTree>
     <p:extLst>
       <p:ext uri="{BB962C8B-B14F-4D97-AF65-F5344CB8AC3E}">
-        <p14:creationId xmlns:p14="http://schemas.microsoft.com/office/powerpoint/2010/main" val="143496216"/>
+        <p14:creationId xmlns:p14="http://schemas.microsoft.com/office/powerpoint/2010/main" val="1665401035"/>
       </p:ext>
     </p:extLst>
   </p:cSld>
@@ -6977,10 +7303,10 @@
       </p:grpSpPr>
       <p:sp>
         <p:nvSpPr>
-          <p:cNvPr id="5" name="">
+          <p:cNvPr id="4" name="">
             <a:extLst xmlns:a="http://schemas.openxmlformats.org/drawingml/2006/main">
               <a:ext uri="{FF2B5EF4-FFF2-40B4-BE49-F238E27FC236}">
-                <a16:creationId xmlns:a16="http://schemas.microsoft.com/office/drawing/2014/main" id="{0A4207E1-F7F1-44D5-B4C9-2930B2E6FFF4}"/>
+                <a16:creationId xmlns:a16="http://schemas.microsoft.com/office/drawing/2014/main" id="{D936ABE6-3AB2-4211-A7A2-58A3986A5F68}"/>
               </a:ext>
             </a:extLst>
           </p:cNvPr>
@@ -6991,8 +7317,8 @@
         </p:nvSpPr>
         <p:spPr>
           <a:xfrm xmlns:a="http://schemas.openxmlformats.org/drawingml/2006/main">
-            <a:off x="685800" y="514350"/>
-            <a:ext cx="8572500" cy="457200"/>
+            <a:off x="685800" y="457200"/>
+            <a:ext cx="9525000" cy="438150"/>
           </a:xfrm>
           <a:prstGeom xmlns:a="http://schemas.openxmlformats.org/drawingml/2006/main" prst="rect">
             <a:avLst/>
@@ -7008,7 +7334,7 @@
           </a:bodyPr>
           <a:lstStyle xmlns:a="http://schemas.openxmlformats.org/drawingml/2006/main">
             <a:defPPr algn="l">
-              <a:defRPr sz="2700" b="1">
+              <a:defRPr sz="2550" b="1">
                 <a:solidFill>
                   <a:srgbClr val="12100F"/>
                 </a:solidFill>
@@ -7024,7 +7350,7 @@
                 <a:spcPct val="115000"/>
               </a:lnSpc>
               <a:buNone/>
-              <a:defRPr sz="2700" b="1">
+              <a:defRPr sz="2550" b="1">
                 <a:solidFill>
                   <a:srgbClr val="12100F"/>
                 </a:solidFill>
@@ -7034,7 +7360,7 @@
               </a:defRPr>
             </a:pPr>
             <a:r>
-              <a:rPr sz="2700" b="1">
+              <a:rPr sz="2550" b="1">
                 <a:solidFill>
                   <a:srgbClr val="12100F"/>
                 </a:solidFill>
@@ -7042,7 +7368,7 @@
                 <a:ea typeface="Lato"/>
                 <a:cs typeface="Lato"/>
               </a:rPr>
-              <a:t>The reveal</a:t>
+              <a:t>The agenda carries the meeting</a:t>
             </a:r>
           </a:p>
         </p:txBody>
@@ -7052,7 +7378,7 @@
           <p:cNvPr id="2" name="">
             <a:extLst xmlns:a="http://schemas.openxmlformats.org/drawingml/2006/main">
               <a:ext uri="{FF2B5EF4-FFF2-40B4-BE49-F238E27FC236}">
-                <a16:creationId xmlns:a16="http://schemas.microsoft.com/office/drawing/2014/main" id="{FE9F7F68-0F92-4FD2-8C7A-3AD923F67FA1}"/>
+                <a16:creationId xmlns:a16="http://schemas.microsoft.com/office/drawing/2014/main" id="{51462406-29CE-4421-BC0B-7832727BEA80}"/>
               </a:ext>
             </a:extLst>
           </p:cNvPr>
@@ -7063,8 +7389,8 @@
         </p:nvSpPr>
         <p:spPr>
           <a:xfrm xmlns:a="http://schemas.openxmlformats.org/drawingml/2006/main">
-            <a:off x="685800" y="1009650"/>
-            <a:ext cx="9906000" cy="571500"/>
+            <a:off x="685800" y="933450"/>
+            <a:ext cx="10096500" cy="533400"/>
           </a:xfrm>
           <a:prstGeom xmlns:a="http://schemas.openxmlformats.org/drawingml/2006/main" prst="rect">
             <a:avLst/>
@@ -7080,7 +7406,7 @@
           </a:bodyPr>
           <a:lstStyle xmlns:a="http://schemas.openxmlformats.org/drawingml/2006/main">
             <a:defPPr algn="l">
-              <a:defRPr sz="1425" b="0">
+              <a:defRPr sz="1350" b="0">
                 <a:solidFill>
                   <a:srgbClr val="6B6762"/>
                 </a:solidFill>
@@ -7096,7 +7422,7 @@
                 <a:spcPct val="115000"/>
               </a:lnSpc>
               <a:buNone/>
-              <a:defRPr sz="1425" b="0">
+              <a:defRPr sz="1350" b="0">
                 <a:solidFill>
                   <a:srgbClr val="6B6762"/>
                 </a:solidFill>
@@ -7106,7 +7432,7 @@
               </a:defRPr>
             </a:pPr>
             <a:r>
-              <a:rPr sz="1425" b="0">
+              <a:rPr sz="1350" b="0">
                 <a:solidFill>
                   <a:srgbClr val="6B6762"/>
                 </a:solidFill>
@@ -7114,7 +7440,7 @@
                 <a:ea typeface="Lato"/>
                 <a:cs typeface="Lato"/>
               </a:rPr>
-              <a:t>The host reveals once and the right answers are scored together. Ten points, plus five for a quick answer.</a:t>
+              <a:t>Agenda 1 of 4, the item under discussion, and everything the room produced on it.</a:t>
             </a:r>
           </a:p>
         </p:txBody>
@@ -7124,7 +7450,7 @@
           <p:cNvPr id="3" name="">
             <a:extLst xmlns:a="http://schemas.openxmlformats.org/drawingml/2006/main">
               <a:ext uri="{FF2B5EF4-FFF2-40B4-BE49-F238E27FC236}">
-                <a16:creationId xmlns:a16="http://schemas.microsoft.com/office/drawing/2014/main" id="{8D3A41DC-5CDC-4915-95DB-9FDCFC5A12AD}"/>
+                <a16:creationId xmlns:a16="http://schemas.microsoft.com/office/drawing/2014/main" id="{19CBF49D-CE2C-4D82-8BE2-0D864256CDE4}"/>
               </a:ext>
             </a:extLst>
           </p:cNvPr>
@@ -7134,47 +7460,17 @@
           <p:nvPr/>
         </p:nvPicPr>
         <p:blipFill>
-          <a:blip xmlns:r="http://schemas.openxmlformats.org/officeDocument/2006/relationships" xmlns:a="http://schemas.openxmlformats.org/drawingml/2006/main" r:embed="Rca7f567ea29c45b4"/>
+          <a:blip xmlns:r="http://schemas.openxmlformats.org/officeDocument/2006/relationships" xmlns:a="http://schemas.openxmlformats.org/drawingml/2006/main" r:embed="R5267305ab2e44bb8"/>
           <a:stretch xmlns:a="http://schemas.openxmlformats.org/drawingml/2006/main"/>
         </p:blipFill>
         <p:spPr>
           <a:xfrm xmlns:a="http://schemas.openxmlformats.org/drawingml/2006/main">
-            <a:off x="685800" y="2478881"/>
-            <a:ext cx="5257800" cy="2957513"/>
+            <a:off x="1811867" y="1809750"/>
+            <a:ext cx="8568267" cy="4819650"/>
           </a:xfrm>
           <a:prstGeom xmlns:a="http://schemas.openxmlformats.org/drawingml/2006/main" prst="roundRect">
             <a:avLst>
-              <a:gd name="adj" fmla="val 3859"/>
-            </a:avLst>
-          </a:prstGeom>
-        </p:spPr>
-      </p:pic>
-      <p:pic>
-        <p:nvPicPr>
-          <p:cNvPr id="4" name="">
-            <a:extLst xmlns:a="http://schemas.openxmlformats.org/drawingml/2006/main">
-              <a:ext uri="{FF2B5EF4-FFF2-40B4-BE49-F238E27FC236}">
-                <a16:creationId xmlns:a16="http://schemas.microsoft.com/office/drawing/2014/main" id="{23236F80-4059-47E9-BF50-6F16EE9473C0}"/>
-              </a:ext>
-            </a:extLst>
-          </p:cNvPr>
-          <p:cNvPicPr>
-            <a:picLocks xmlns:a="http://schemas.openxmlformats.org/drawingml/2006/main" noChangeAspect="1"/>
-          </p:cNvPicPr>
-          <p:nvPr/>
-        </p:nvPicPr>
-        <p:blipFill>
-          <a:blip xmlns:r="http://schemas.openxmlformats.org/officeDocument/2006/relationships" xmlns:a="http://schemas.openxmlformats.org/drawingml/2006/main" r:embed="R8c7c3bb3355345ed"/>
-          <a:stretch xmlns:a="http://schemas.openxmlformats.org/drawingml/2006/main"/>
-        </p:blipFill>
-        <p:spPr>
-          <a:xfrm xmlns:a="http://schemas.openxmlformats.org/drawingml/2006/main">
-            <a:off x="6248400" y="2478881"/>
-            <a:ext cx="5257800" cy="2957513"/>
-          </a:xfrm>
-          <a:prstGeom xmlns:a="http://schemas.openxmlformats.org/drawingml/2006/main" prst="roundRect">
-            <a:avLst>
-              <a:gd name="adj" fmla="val 3859"/>
+              <a:gd name="adj" fmla="val 2372"/>
             </a:avLst>
           </a:prstGeom>
         </p:spPr>
@@ -7182,7 +7478,7 @@
     </p:spTree>
     <p:extLst>
       <p:ext uri="{BB962C8B-B14F-4D97-AF65-F5344CB8AC3E}">
-        <p14:creationId xmlns:p14="http://schemas.microsoft.com/office/powerpoint/2010/main" val="90285941"/>
+        <p14:creationId xmlns:p14="http://schemas.microsoft.com/office/powerpoint/2010/main" val="1732493719"/>
       </p:ext>
     </p:extLst>
   </p:cSld>
@@ -7213,7 +7509,7 @@
           <p:cNvPr id="5" name="">
             <a:extLst xmlns:a="http://schemas.openxmlformats.org/drawingml/2006/main">
               <a:ext uri="{FF2B5EF4-FFF2-40B4-BE49-F238E27FC236}">
-                <a16:creationId xmlns:a16="http://schemas.microsoft.com/office/drawing/2014/main" id="{9BC0C9FF-3CEB-41E0-A921-9CC34B9DFA86}"/>
+                <a16:creationId xmlns:a16="http://schemas.microsoft.com/office/drawing/2014/main" id="{BFB9A28E-FB4D-438B-ACC3-9C3CC511BE04}"/>
               </a:ext>
             </a:extLst>
           </p:cNvPr>
@@ -7224,8 +7520,8 @@
         </p:nvSpPr>
         <p:spPr>
           <a:xfrm xmlns:a="http://schemas.openxmlformats.org/drawingml/2006/main">
-            <a:off x="685800" y="514350"/>
-            <a:ext cx="8572500" cy="457200"/>
+            <a:off x="685800" y="457200"/>
+            <a:ext cx="9525000" cy="438150"/>
           </a:xfrm>
           <a:prstGeom xmlns:a="http://schemas.openxmlformats.org/drawingml/2006/main" prst="rect">
             <a:avLst/>
@@ -7241,7 +7537,7 @@
           </a:bodyPr>
           <a:lstStyle xmlns:a="http://schemas.openxmlformats.org/drawingml/2006/main">
             <a:defPPr algn="l">
-              <a:defRPr sz="2700" b="1">
+              <a:defRPr sz="2550" b="1">
                 <a:solidFill>
                   <a:srgbClr val="12100F"/>
                 </a:solidFill>
@@ -7257,7 +7553,7 @@
                 <a:spcPct val="115000"/>
               </a:lnSpc>
               <a:buNone/>
-              <a:defRPr sz="2700" b="1">
+              <a:defRPr sz="2550" b="1">
                 <a:solidFill>
                   <a:srgbClr val="12100F"/>
                 </a:solidFill>
@@ -7267,7 +7563,7 @@
               </a:defRPr>
             </a:pPr>
             <a:r>
-              <a:rPr sz="2700" b="1">
+              <a:rPr sz="2550" b="1">
                 <a:solidFill>
                   <a:srgbClr val="12100F"/>
                 </a:solidFill>
@@ -7275,7 +7571,7 @@
                 <a:ea typeface="Lato"/>
                 <a:cs typeface="Lato"/>
               </a:rPr>
-              <a:t>Capturing an idea</a:t>
+              <a:t>Everybody follows, and can add</a:t>
             </a:r>
           </a:p>
         </p:txBody>
@@ -7285,7 +7581,7 @@
           <p:cNvPr id="2" name="">
             <a:extLst xmlns:a="http://schemas.openxmlformats.org/drawingml/2006/main">
               <a:ext uri="{FF2B5EF4-FFF2-40B4-BE49-F238E27FC236}">
-                <a16:creationId xmlns:a16="http://schemas.microsoft.com/office/drawing/2014/main" id="{BBF0925B-FEB9-4490-AB9B-E6761D0857E9}"/>
+                <a16:creationId xmlns:a16="http://schemas.microsoft.com/office/drawing/2014/main" id="{7BAA5716-B6FA-4721-A66D-3232808676E2}"/>
               </a:ext>
             </a:extLst>
           </p:cNvPr>
@@ -7296,8 +7592,8 @@
         </p:nvSpPr>
         <p:spPr>
           <a:xfrm xmlns:a="http://schemas.openxmlformats.org/drawingml/2006/main">
-            <a:off x="685800" y="1009650"/>
-            <a:ext cx="9906000" cy="571500"/>
+            <a:off x="685800" y="933450"/>
+            <a:ext cx="10096500" cy="533400"/>
           </a:xfrm>
           <a:prstGeom xmlns:a="http://schemas.openxmlformats.org/drawingml/2006/main" prst="rect">
             <a:avLst/>
@@ -7313,7 +7609,7 @@
           </a:bodyPr>
           <a:lstStyle xmlns:a="http://schemas.openxmlformats.org/drawingml/2006/main">
             <a:defPPr algn="l">
-              <a:defRPr sz="1425" b="0">
+              <a:defRPr sz="1350" b="0">
                 <a:solidFill>
                   <a:srgbClr val="6B6762"/>
                 </a:solidFill>
@@ -7329,7 +7625,7 @@
                 <a:spcPct val="115000"/>
               </a:lnSpc>
               <a:buNone/>
-              <a:defRPr sz="1425" b="0">
+              <a:defRPr sz="1350" b="0">
                 <a:solidFill>
                   <a:srgbClr val="6B6762"/>
                 </a:solidFill>
@@ -7339,7 +7635,7 @@
               </a:defRPr>
             </a:pPr>
             <a:r>
-              <a:rPr sz="1425" b="0">
+              <a:rPr sz="1350" b="0">
                 <a:solidFill>
                   <a:srgbClr val="6B6762"/>
                 </a:solidFill>
@@ -7347,7 +7643,7 @@
                 <a:ea typeface="Lato"/>
                 <a:cs typeface="Lato"/>
               </a:rPr>
-              <a:t>One line, saved in seconds. You stay exactly where you were in the meeting.</a:t>
+              <a:t>Participants see the same item, and can note something or propose an idea without leaving the meeting.</a:t>
             </a:r>
           </a:p>
         </p:txBody>
@@ -7357,7 +7653,7 @@
           <p:cNvPr id="3" name="">
             <a:extLst xmlns:a="http://schemas.openxmlformats.org/drawingml/2006/main">
               <a:ext uri="{FF2B5EF4-FFF2-40B4-BE49-F238E27FC236}">
-                <a16:creationId xmlns:a16="http://schemas.microsoft.com/office/drawing/2014/main" id="{A6561EB5-8292-4DC9-961E-CAE30CFF9FA7}"/>
+                <a16:creationId xmlns:a16="http://schemas.microsoft.com/office/drawing/2014/main" id="{A03C9C18-A69A-4DE2-9E72-F706847B529C}"/>
               </a:ext>
             </a:extLst>
           </p:cNvPr>
@@ -7367,17 +7663,17 @@
           <p:nvPr/>
         </p:nvPicPr>
         <p:blipFill>
-          <a:blip xmlns:r="http://schemas.openxmlformats.org/officeDocument/2006/relationships" xmlns:a="http://schemas.openxmlformats.org/drawingml/2006/main" r:embed="Rda0fced656e44fef"/>
+          <a:blip xmlns:r="http://schemas.openxmlformats.org/officeDocument/2006/relationships" xmlns:a="http://schemas.openxmlformats.org/drawingml/2006/main" r:embed="Ra1c5407a65a3431e"/>
           <a:stretch xmlns:a="http://schemas.openxmlformats.org/drawingml/2006/main"/>
         </p:blipFill>
         <p:spPr>
           <a:xfrm xmlns:a="http://schemas.openxmlformats.org/drawingml/2006/main">
-            <a:off x="3429000" y="2047875"/>
-            <a:ext cx="8077200" cy="4543425"/>
+            <a:off x="915348" y="1905000"/>
+            <a:ext cx="2112654" cy="4572000"/>
           </a:xfrm>
           <a:prstGeom xmlns:a="http://schemas.openxmlformats.org/drawingml/2006/main" prst="roundRect">
             <a:avLst>
-              <a:gd name="adj" fmla="val 2516"/>
+              <a:gd name="adj" fmla="val 5405"/>
             </a:avLst>
           </a:prstGeom>
         </p:spPr>
@@ -7387,7 +7683,7 @@
           <p:cNvPr id="4" name="">
             <a:extLst xmlns:a="http://schemas.openxmlformats.org/drawingml/2006/main">
               <a:ext uri="{FF2B5EF4-FFF2-40B4-BE49-F238E27FC236}">
-                <a16:creationId xmlns:a16="http://schemas.microsoft.com/office/drawing/2014/main" id="{3B816A79-604B-4F44-BFB2-762D672C6979}"/>
+                <a16:creationId xmlns:a16="http://schemas.microsoft.com/office/drawing/2014/main" id="{D8C58CC9-B931-40B6-BDD6-F87738713CBE}"/>
               </a:ext>
             </a:extLst>
           </p:cNvPr>
@@ -7397,17 +7693,17 @@
           <p:nvPr/>
         </p:nvPicPr>
         <p:blipFill>
-          <a:blip xmlns:r="http://schemas.openxmlformats.org/officeDocument/2006/relationships" xmlns:a="http://schemas.openxmlformats.org/drawingml/2006/main" r:embed="R07975911e0284c33"/>
+          <a:blip xmlns:r="http://schemas.openxmlformats.org/officeDocument/2006/relationships" xmlns:a="http://schemas.openxmlformats.org/drawingml/2006/main" r:embed="R969237c48ceb4543"/>
           <a:stretch xmlns:a="http://schemas.openxmlformats.org/drawingml/2006/main"/>
         </p:blipFill>
         <p:spPr>
           <a:xfrm xmlns:a="http://schemas.openxmlformats.org/drawingml/2006/main">
-            <a:off x="915348" y="2000250"/>
-            <a:ext cx="2112654" cy="4572000"/>
+            <a:off x="3810000" y="2049066"/>
+            <a:ext cx="7734300" cy="4350544"/>
           </a:xfrm>
           <a:prstGeom xmlns:a="http://schemas.openxmlformats.org/drawingml/2006/main" prst="roundRect">
             <a:avLst>
-              <a:gd name="adj" fmla="val 5405"/>
+              <a:gd name="adj" fmla="val 2626"/>
             </a:avLst>
           </a:prstGeom>
         </p:spPr>
@@ -7415,7 +7711,7 @@
     </p:spTree>
     <p:extLst>
       <p:ext uri="{BB962C8B-B14F-4D97-AF65-F5344CB8AC3E}">
-        <p14:creationId xmlns:p14="http://schemas.microsoft.com/office/powerpoint/2010/main" val="76024594"/>
+        <p14:creationId xmlns:p14="http://schemas.microsoft.com/office/powerpoint/2010/main" val="745064016"/>
       </p:ext>
     </p:extLst>
   </p:cSld>
@@ -7446,7 +7742,7 @@
           <p:cNvPr id="5" name="">
             <a:extLst xmlns:a="http://schemas.openxmlformats.org/drawingml/2006/main">
               <a:ext uri="{FF2B5EF4-FFF2-40B4-BE49-F238E27FC236}">
-                <a16:creationId xmlns:a16="http://schemas.microsoft.com/office/drawing/2014/main" id="{3B752750-B079-494F-8555-527AC307B833}"/>
+                <a16:creationId xmlns:a16="http://schemas.microsoft.com/office/drawing/2014/main" id="{30038FFC-E37E-4525-8795-F2D4749E18B2}"/>
               </a:ext>
             </a:extLst>
           </p:cNvPr>
@@ -7457,8 +7753,8 @@
         </p:nvSpPr>
         <p:spPr>
           <a:xfrm xmlns:a="http://schemas.openxmlformats.org/drawingml/2006/main">
-            <a:off x="685800" y="514350"/>
-            <a:ext cx="8572500" cy="457200"/>
+            <a:off x="685800" y="457200"/>
+            <a:ext cx="9525000" cy="438150"/>
           </a:xfrm>
           <a:prstGeom xmlns:a="http://schemas.openxmlformats.org/drawingml/2006/main" prst="rect">
             <a:avLst/>
@@ -7474,7 +7770,7 @@
           </a:bodyPr>
           <a:lstStyle xmlns:a="http://schemas.openxmlformats.org/drawingml/2006/main">
             <a:defPPr algn="l">
-              <a:defRPr sz="2700" b="1">
+              <a:defRPr sz="2550" b="1">
                 <a:solidFill>
                   <a:srgbClr val="12100F"/>
                 </a:solidFill>
@@ -7490,7 +7786,7 @@
                 <a:spcPct val="115000"/>
               </a:lnSpc>
               <a:buNone/>
-              <a:defRPr sz="2700" b="1">
+              <a:defRPr sz="2550" b="1">
                 <a:solidFill>
                   <a:srgbClr val="12100F"/>
                 </a:solidFill>
@@ -7500,7 +7796,7 @@
               </a:defRPr>
             </a:pPr>
             <a:r>
-              <a:rPr sz="2700" b="1">
+              <a:rPr sz="2550" b="1">
                 <a:solidFill>
                   <a:srgbClr val="12100F"/>
                 </a:solidFill>
@@ -7518,7 +7814,7 @@
           <p:cNvPr id="2" name="">
             <a:extLst xmlns:a="http://schemas.openxmlformats.org/drawingml/2006/main">
               <a:ext uri="{FF2B5EF4-FFF2-40B4-BE49-F238E27FC236}">
-                <a16:creationId xmlns:a16="http://schemas.microsoft.com/office/drawing/2014/main" id="{A3EDE9D0-34ED-465F-B93E-AD0EDDA55225}"/>
+                <a16:creationId xmlns:a16="http://schemas.microsoft.com/office/drawing/2014/main" id="{CE2D8CB1-55E1-41EC-94D5-A1F97573D4EC}"/>
               </a:ext>
             </a:extLst>
           </p:cNvPr>
@@ -7529,8 +7825,8 @@
         </p:nvSpPr>
         <p:spPr>
           <a:xfrm xmlns:a="http://schemas.openxmlformats.org/drawingml/2006/main">
-            <a:off x="685800" y="1009650"/>
-            <a:ext cx="9906000" cy="571500"/>
+            <a:off x="685800" y="933450"/>
+            <a:ext cx="10096500" cy="533400"/>
           </a:xfrm>
           <a:prstGeom xmlns:a="http://schemas.openxmlformats.org/drawingml/2006/main" prst="rect">
             <a:avLst/>
@@ -7546,7 +7842,7 @@
           </a:bodyPr>
           <a:lstStyle xmlns:a="http://schemas.openxmlformats.org/drawingml/2006/main">
             <a:defPPr algn="l">
-              <a:defRPr sz="1425" b="0">
+              <a:defRPr sz="1350" b="0">
                 <a:solidFill>
                   <a:srgbClr val="6B6762"/>
                 </a:solidFill>
@@ -7562,7 +7858,7 @@
                 <a:spcPct val="115000"/>
               </a:lnSpc>
               <a:buNone/>
-              <a:defRPr sz="1425" b="0">
+              <a:defRPr sz="1350" b="0">
                 <a:solidFill>
                   <a:srgbClr val="6B6762"/>
                 </a:solidFill>
@@ -7572,7 +7868,7 @@
               </a:defRPr>
             </a:pPr>
             <a:r>
-              <a:rPr sz="1425" b="0">
+              <a:rPr sz="1350" b="0">
                 <a:solidFill>
                   <a:srgbClr val="6B6762"/>
                 </a:solidFill>
@@ -7580,7 +7876,7 @@
                 <a:ea typeface="Lato"/>
                 <a:cs typeface="Lato"/>
               </a:rPr>
-              <a:t>The decision and the task keep the idea that started them, so nobody has to remember.</a:t>
+              <a:t>The decision and the action keep the item they came from, so nobody has to remember.</a:t>
             </a:r>
           </a:p>
         </p:txBody>
@@ -7590,7 +7886,7 @@
           <p:cNvPr id="3" name="">
             <a:extLst xmlns:a="http://schemas.openxmlformats.org/drawingml/2006/main">
               <a:ext uri="{FF2B5EF4-FFF2-40B4-BE49-F238E27FC236}">
-                <a16:creationId xmlns:a16="http://schemas.microsoft.com/office/drawing/2014/main" id="{0D86A6BD-AF22-4110-8196-0A704AACA03A}"/>
+                <a16:creationId xmlns:a16="http://schemas.microsoft.com/office/drawing/2014/main" id="{2153FCF3-6021-45B3-B9E6-1998F9829E73}"/>
               </a:ext>
             </a:extLst>
           </p:cNvPr>
@@ -7600,12 +7896,12 @@
           <p:nvPr/>
         </p:nvPicPr>
         <p:blipFill>
-          <a:blip xmlns:r="http://schemas.openxmlformats.org/officeDocument/2006/relationships" xmlns:a="http://schemas.openxmlformats.org/drawingml/2006/main" r:embed="R1c63ec9d8ae34a1c"/>
+          <a:blip xmlns:r="http://schemas.openxmlformats.org/officeDocument/2006/relationships" xmlns:a="http://schemas.openxmlformats.org/drawingml/2006/main" r:embed="Ra667d2a127494a5b"/>
           <a:stretch xmlns:a="http://schemas.openxmlformats.org/drawingml/2006/main"/>
         </p:blipFill>
         <p:spPr>
           <a:xfrm xmlns:a="http://schemas.openxmlformats.org/drawingml/2006/main">
-            <a:off x="685800" y="2478881"/>
+            <a:off x="685800" y="2383631"/>
             <a:ext cx="5257800" cy="2957513"/>
           </a:xfrm>
           <a:prstGeom xmlns:a="http://schemas.openxmlformats.org/drawingml/2006/main" prst="roundRect">
@@ -7620,7 +7916,7 @@
           <p:cNvPr id="4" name="">
             <a:extLst xmlns:a="http://schemas.openxmlformats.org/drawingml/2006/main">
               <a:ext uri="{FF2B5EF4-FFF2-40B4-BE49-F238E27FC236}">
-                <a16:creationId xmlns:a16="http://schemas.microsoft.com/office/drawing/2014/main" id="{5C2EF582-C660-4AA0-B0BB-761D0E81734E}"/>
+                <a16:creationId xmlns:a16="http://schemas.microsoft.com/office/drawing/2014/main" id="{0B988103-0F00-4352-8219-5F4624DD135C}"/>
               </a:ext>
             </a:extLst>
           </p:cNvPr>
@@ -7630,12 +7926,12 @@
           <p:nvPr/>
         </p:nvPicPr>
         <p:blipFill>
-          <a:blip xmlns:r="http://schemas.openxmlformats.org/officeDocument/2006/relationships" xmlns:a="http://schemas.openxmlformats.org/drawingml/2006/main" r:embed="R12519713fb62486b"/>
+          <a:blip xmlns:r="http://schemas.openxmlformats.org/officeDocument/2006/relationships" xmlns:a="http://schemas.openxmlformats.org/drawingml/2006/main" r:embed="R7b8afa135b56406c"/>
           <a:stretch xmlns:a="http://schemas.openxmlformats.org/drawingml/2006/main"/>
         </p:blipFill>
         <p:spPr>
           <a:xfrm xmlns:a="http://schemas.openxmlformats.org/drawingml/2006/main">
-            <a:off x="6248400" y="2478881"/>
+            <a:off x="6248400" y="2383631"/>
             <a:ext cx="5257800" cy="2957513"/>
           </a:xfrm>
           <a:prstGeom xmlns:a="http://schemas.openxmlformats.org/drawingml/2006/main" prst="roundRect">
@@ -7648,7 +7944,7 @@
     </p:spTree>
     <p:extLst>
       <p:ext uri="{BB962C8B-B14F-4D97-AF65-F5344CB8AC3E}">
-        <p14:creationId xmlns:p14="http://schemas.microsoft.com/office/powerpoint/2010/main" val="1846853087"/>
+        <p14:creationId xmlns:p14="http://schemas.microsoft.com/office/powerpoint/2010/main" val="77752735"/>
       </p:ext>
     </p:extLst>
   </p:cSld>

</xml_diff>